<commit_message>
Update day 2 presentation
</commit_message>
<xml_diff>
--- a/заняття_2/python_lesson2.pptx
+++ b/заняття_2/python_lesson2.pptx
@@ -5,7 +5,7 @@
     <p:sldMasterId id="2147483648" r:id="rId1"/>
   </p:sldMasterIdLst>
   <p:notesMasterIdLst>
-    <p:notesMasterId r:id="rId17"/>
+    <p:notesMasterId r:id="rId19"/>
   </p:notesMasterIdLst>
   <p:sldIdLst>
     <p:sldId id="256" r:id="rId2"/>
@@ -22,7 +22,9 @@
     <p:sldId id="267" r:id="rId13"/>
     <p:sldId id="268" r:id="rId14"/>
     <p:sldId id="269" r:id="rId15"/>
-    <p:sldId id="270" r:id="rId16"/>
+    <p:sldId id="271" r:id="rId16"/>
+    <p:sldId id="272" r:id="rId17"/>
+    <p:sldId id="270" r:id="rId18"/>
   </p:sldIdLst>
   <p:sldSz cx="9144000" cy="5143500" type="screen16x9"/>
   <p:notesSz cx="5143500" cy="9144000"/>
@@ -839,6 +841,174 @@
 </p:notes>
 </file>
 
+<file path=ppt/notesSlides/notesSlide16.xml><?xml version="1.0" encoding="utf-8"?>
+<p:notes xmlns:a="http://schemas.openxmlformats.org/drawingml/2006/main" xmlns:r="http://schemas.openxmlformats.org/officeDocument/2006/relationships" xmlns:p="http://schemas.openxmlformats.org/presentationml/2006/main">
+  <p:cSld>
+    <p:spTree>
+      <p:nvGrpSpPr>
+        <p:cNvPr id="1" name=""/>
+        <p:cNvGrpSpPr/>
+        <p:nvPr/>
+      </p:nvGrpSpPr>
+      <p:grpSpPr>
+        <a:xfrm>
+          <a:off x="0" y="0"/>
+          <a:ext cx="0" cy="0"/>
+          <a:chOff x="0" y="0"/>
+          <a:chExt cx="0" cy="0"/>
+        </a:xfrm>
+      </p:grpSpPr>
+      <p:sp>
+        <p:nvSpPr>
+          <p:cNvPr id="2" name="Slide Image Placeholder 1"/>
+          <p:cNvSpPr>
+            <a:spLocks noGrp="1" noRot="1" noChangeAspect="1"/>
+          </p:cNvSpPr>
+          <p:nvPr>
+            <p:ph type="sldImg"/>
+          </p:nvPr>
+        </p:nvSpPr>
+        <p:spPr/>
+      </p:sp>
+      <p:sp>
+        <p:nvSpPr>
+          <p:cNvPr id="3" name="Notes Placeholder 2"/>
+          <p:cNvSpPr>
+            <a:spLocks noGrp="1"/>
+          </p:cNvSpPr>
+          <p:nvPr>
+            <p:ph type="body" idx="1"/>
+          </p:nvPr>
+        </p:nvSpPr>
+        <p:spPr/>
+        <p:txBody>
+          <a:bodyPr/>
+          <a:lstStyle/>
+          <a:p>
+            <a:endParaRPr lang="en-US" dirty="0"/>
+          </a:p>
+        </p:txBody>
+      </p:sp>
+      <p:sp>
+        <p:nvSpPr>
+          <p:cNvPr id="4" name="Slide Number Placeholder 3"/>
+          <p:cNvSpPr>
+            <a:spLocks noGrp="1"/>
+          </p:cNvSpPr>
+          <p:nvPr>
+            <p:ph type="sldNum" sz="quarter" idx="10"/>
+          </p:nvPr>
+        </p:nvSpPr>
+        <p:spPr/>
+        <p:txBody>
+          <a:bodyPr/>
+          <a:lstStyle/>
+          <a:p>
+            <a:fld id="{F7021451-1387-4CA6-816F-3879F97B5CBC}" type="slidenum">
+              <a:rPr lang="en-US"/>
+              <a:t>16</a:t>
+            </a:fld>
+            <a:endParaRPr lang="en-US"/>
+          </a:p>
+        </p:txBody>
+      </p:sp>
+    </p:spTree>
+    <p:extLst>
+      <p:ext uri="{BB962C8B-B14F-4D97-AF65-F5344CB8AC3E}">
+        <p14:creationId xmlns:p14="http://schemas.microsoft.com/office/powerpoint/2010/main" val="1024086991"/>
+      </p:ext>
+    </p:extLst>
+  </p:cSld>
+  <p:clrMapOvr>
+    <a:masterClrMapping/>
+  </p:clrMapOvr>
+</p:notes>
+</file>
+
+<file path=ppt/notesSlides/notesSlide17.xml><?xml version="1.0" encoding="utf-8"?>
+<p:notes xmlns:a="http://schemas.openxmlformats.org/drawingml/2006/main" xmlns:r="http://schemas.openxmlformats.org/officeDocument/2006/relationships" xmlns:p="http://schemas.openxmlformats.org/presentationml/2006/main">
+  <p:cSld>
+    <p:spTree>
+      <p:nvGrpSpPr>
+        <p:cNvPr id="1" name=""/>
+        <p:cNvGrpSpPr/>
+        <p:nvPr/>
+      </p:nvGrpSpPr>
+      <p:grpSpPr>
+        <a:xfrm>
+          <a:off x="0" y="0"/>
+          <a:ext cx="0" cy="0"/>
+          <a:chOff x="0" y="0"/>
+          <a:chExt cx="0" cy="0"/>
+        </a:xfrm>
+      </p:grpSpPr>
+      <p:sp>
+        <p:nvSpPr>
+          <p:cNvPr id="2" name="Slide Image Placeholder 1"/>
+          <p:cNvSpPr>
+            <a:spLocks noGrp="1" noRot="1" noChangeAspect="1"/>
+          </p:cNvSpPr>
+          <p:nvPr>
+            <p:ph type="sldImg"/>
+          </p:nvPr>
+        </p:nvSpPr>
+        <p:spPr/>
+      </p:sp>
+      <p:sp>
+        <p:nvSpPr>
+          <p:cNvPr id="3" name="Notes Placeholder 2"/>
+          <p:cNvSpPr>
+            <a:spLocks noGrp="1"/>
+          </p:cNvSpPr>
+          <p:nvPr>
+            <p:ph type="body" idx="1"/>
+          </p:nvPr>
+        </p:nvSpPr>
+        <p:spPr/>
+        <p:txBody>
+          <a:bodyPr/>
+          <a:lstStyle/>
+          <a:p>
+            <a:endParaRPr lang="en-US" dirty="0"/>
+          </a:p>
+        </p:txBody>
+      </p:sp>
+      <p:sp>
+        <p:nvSpPr>
+          <p:cNvPr id="4" name="Slide Number Placeholder 3"/>
+          <p:cNvSpPr>
+            <a:spLocks noGrp="1"/>
+          </p:cNvSpPr>
+          <p:nvPr>
+            <p:ph type="sldNum" sz="quarter" idx="10"/>
+          </p:nvPr>
+        </p:nvSpPr>
+        <p:spPr/>
+        <p:txBody>
+          <a:bodyPr/>
+          <a:lstStyle/>
+          <a:p>
+            <a:fld id="{F7021451-1387-4CA6-816F-3879F97B5CBC}" type="slidenum">
+              <a:rPr lang="en-US"/>
+              <a:t>17</a:t>
+            </a:fld>
+            <a:endParaRPr lang="en-US"/>
+          </a:p>
+        </p:txBody>
+      </p:sp>
+    </p:spTree>
+    <p:extLst>
+      <p:ext uri="{BB962C8B-B14F-4D97-AF65-F5344CB8AC3E}">
+        <p14:creationId xmlns:p14="http://schemas.microsoft.com/office/powerpoint/2010/main" val="1024086991"/>
+      </p:ext>
+    </p:extLst>
+  </p:cSld>
+  <p:clrMapOvr>
+    <a:masterClrMapping/>
+  </p:clrMapOvr>
+</p:notes>
+</file>
+
 <file path=ppt/notesSlides/notesSlide2.xml><?xml version="1.0" encoding="utf-8"?>
 <p:notes xmlns:a="http://schemas.openxmlformats.org/drawingml/2006/main" xmlns:r="http://schemas.openxmlformats.org/officeDocument/2006/relationships" xmlns:p="http://schemas.openxmlformats.org/presentationml/2006/main">
   <p:cSld>
@@ -7557,6 +7727,4008 @@
 </file>
 
 <file path=ppt/slides/slide15.xml><?xml version="1.0" encoding="utf-8"?>
+<p:sld xmlns:a="http://schemas.openxmlformats.org/drawingml/2006/main" xmlns:r="http://schemas.openxmlformats.org/officeDocument/2006/relationships" xmlns:p="http://schemas.openxmlformats.org/presentationml/2006/main">
+  <p:cSld>
+    <p:spTree>
+      <p:nvGrpSpPr>
+        <p:cNvPr id="1" name=""/>
+        <p:cNvGrpSpPr/>
+        <p:nvPr/>
+      </p:nvGrpSpPr>
+      <p:grpSpPr>
+        <a:xfrm>
+          <a:off x="0" y="0"/>
+          <a:ext cx="0" cy="0"/>
+          <a:chOff x="0" y="0"/>
+          <a:chExt cx="0" cy="0"/>
+        </a:xfrm>
+      </p:grpSpPr>
+      <p:sp>
+        <p:nvSpPr>
+          <p:cNvPr id="2" name="Text 0"/>
+          <p:cNvSpPr/>
+          <p:nvPr/>
+        </p:nvSpPr>
+        <p:spPr>
+          <a:xfrm>
+            <a:off x="457200" y="182880"/>
+            <a:ext cx="8229600" cy="658368"/>
+          </a:xfrm>
+          <a:prstGeom prst="rect">
+            <a:avLst/>
+          </a:prstGeom>
+          <a:noFill/>
+          <a:ln/>
+        </p:spPr>
+        <p:txBody>
+          <a:bodyPr wrap="square" lIns="0" tIns="0" rIns="0" bIns="0" rtlCol="0" anchor="ctr"/>
+          <a:lstStyle/>
+          <a:p>
+            <a:pPr marL="0" indent="0">
+              <a:buNone/>
+            </a:pPr>
+            <a:r>
+              <a:rPr lang="en-US" sz="3000" b="1" dirty="0">
+                <a:solidFill>
+                  <a:srgbClr val="1A1F36"/>
+                </a:solidFill>
+                <a:latin typeface="Trebuchet MS" pitchFamily="34" charset="0"/>
+                <a:ea typeface="Trebuchet MS" pitchFamily="34" charset="-122"/>
+                <a:cs typeface="Trebuchet MS" pitchFamily="34" charset="-120"/>
+              </a:rPr>
+              <a:t>Індексація рядків</a:t>
+            </a:r>
+            <a:endParaRPr lang="en-US" sz="3000" dirty="0"/>
+          </a:p>
+        </p:txBody>
+      </p:sp>
+      <p:sp>
+        <p:nvSpPr>
+          <p:cNvPr id="3" name="Shape 1"/>
+          <p:cNvSpPr/>
+          <p:nvPr/>
+        </p:nvSpPr>
+        <p:spPr>
+          <a:xfrm>
+            <a:off x="7589520" y="164592"/>
+            <a:ext cx="1371600" cy="347472"/>
+          </a:xfrm>
+          <a:prstGeom prst="roundRect">
+            <a:avLst>
+              <a:gd name="adj" fmla="val 18421"/>
+            </a:avLst>
+          </a:prstGeom>
+          <a:solidFill>
+            <a:srgbClr val="5B8FF9"/>
+          </a:solidFill>
+          <a:ln w="12700">
+            <a:solidFill>
+              <a:srgbClr val="5B8FF9"/>
+            </a:solidFill>
+            <a:prstDash val="solid"/>
+          </a:ln>
+        </p:spPr>
+        <p:txBody>
+          <a:bodyPr/>
+          <a:lstStyle/>
+          <a:p>
+            <a:endParaRPr lang="en-UA"/>
+          </a:p>
+        </p:txBody>
+      </p:sp>
+      <p:sp>
+        <p:nvSpPr>
+          <p:cNvPr id="4" name="Text 2"/>
+          <p:cNvSpPr/>
+          <p:nvPr/>
+        </p:nvSpPr>
+        <p:spPr>
+          <a:xfrm>
+            <a:off x="7589520" y="164592"/>
+            <a:ext cx="1371600" cy="347472"/>
+          </a:xfrm>
+          <a:prstGeom prst="rect">
+            <a:avLst/>
+          </a:prstGeom>
+          <a:noFill/>
+          <a:ln/>
+        </p:spPr>
+        <p:txBody>
+          <a:bodyPr wrap="square" lIns="0" tIns="0" rIns="0" bIns="0" rtlCol="0" anchor="ctr"/>
+          <a:lstStyle/>
+          <a:p>
+            <a:pPr marL="0" indent="0" algn="ctr">
+              <a:buNone/>
+            </a:pPr>
+            <a:r>
+              <a:rPr lang="en-US" sz="1100" b="1" dirty="0">
+                <a:solidFill>
+                  <a:srgbClr val="FFFFFF"/>
+                </a:solidFill>
+                <a:latin typeface="Calibri" pitchFamily="34" charset="0"/>
+                <a:ea typeface="Calibri" pitchFamily="34" charset="-122"/>
+                <a:cs typeface="Calibri" pitchFamily="34" charset="-120"/>
+              </a:rPr>
+              <a:t>Теорія</a:t>
+            </a:r>
+            <a:endParaRPr lang="en-US" sz="1100" dirty="0"/>
+          </a:p>
+        </p:txBody>
+      </p:sp>
+      <p:sp>
+        <p:nvSpPr>
+          <p:cNvPr id="5" name="Text 3"/>
+          <p:cNvSpPr/>
+          <p:nvPr/>
+        </p:nvSpPr>
+        <p:spPr>
+          <a:xfrm>
+            <a:off x="457200" y="960120"/>
+            <a:ext cx="8229600" cy="384048"/>
+          </a:xfrm>
+          <a:prstGeom prst="rect">
+            <a:avLst/>
+          </a:prstGeom>
+          <a:noFill/>
+          <a:ln/>
+        </p:spPr>
+        <p:txBody>
+          <a:bodyPr wrap="square" lIns="0" tIns="0" rIns="0" bIns="0" rtlCol="0" anchor="ctr"/>
+          <a:lstStyle/>
+          <a:p>
+            <a:pPr marL="0" indent="0">
+              <a:buNone/>
+            </a:pPr>
+            <a:r>
+              <a:rPr lang="en-US" sz="1500" i="1" dirty="0">
+                <a:solidFill>
+                  <a:srgbClr val="7A8BB5"/>
+                </a:solidFill>
+                <a:latin typeface="Calibri" pitchFamily="34" charset="0"/>
+                <a:ea typeface="Calibri" pitchFamily="34" charset="-122"/>
+                <a:cs typeface="Calibri" pitchFamily="34" charset="-120"/>
+              </a:rPr>
+              <a:t>Кожен символ рядка має свій номер (індекс) — рахунок починається з 0</a:t>
+            </a:r>
+            <a:endParaRPr lang="en-US" sz="1500" dirty="0"/>
+          </a:p>
+        </p:txBody>
+      </p:sp>
+      <p:sp>
+        <p:nvSpPr>
+          <p:cNvPr id="6" name="Text 4"/>
+          <p:cNvSpPr/>
+          <p:nvPr/>
+        </p:nvSpPr>
+        <p:spPr>
+          <a:xfrm>
+            <a:off x="173736" y="1348740"/>
+            <a:ext cx="1005840" cy="347472"/>
+          </a:xfrm>
+          <a:prstGeom prst="rect">
+            <a:avLst/>
+          </a:prstGeom>
+          <a:noFill/>
+          <a:ln/>
+        </p:spPr>
+        <p:txBody>
+          <a:bodyPr wrap="square" lIns="0" tIns="0" rIns="0" bIns="0" rtlCol="0" anchor="ctr"/>
+          <a:lstStyle/>
+          <a:p>
+            <a:pPr marL="0" indent="0">
+              <a:buNone/>
+            </a:pPr>
+            <a:r>
+              <a:rPr lang="en-US" sz="1200" dirty="0">
+                <a:solidFill>
+                  <a:srgbClr val="7A8BB5"/>
+                </a:solidFill>
+                <a:latin typeface="Calibri" pitchFamily="34" charset="0"/>
+                <a:ea typeface="Calibri" pitchFamily="34" charset="-122"/>
+                <a:cs typeface="Calibri" pitchFamily="34" charset="-120"/>
+              </a:rPr>
+              <a:t>Індекс:</a:t>
+            </a:r>
+            <a:endParaRPr lang="en-US" sz="1200" dirty="0"/>
+          </a:p>
+        </p:txBody>
+      </p:sp>
+      <p:sp>
+        <p:nvSpPr>
+          <p:cNvPr id="7" name="Shape 5"/>
+          <p:cNvSpPr/>
+          <p:nvPr/>
+        </p:nvSpPr>
+        <p:spPr>
+          <a:xfrm>
+            <a:off x="722376" y="1371600"/>
+            <a:ext cx="566928" cy="320040"/>
+          </a:xfrm>
+          <a:prstGeom prst="roundRect">
+            <a:avLst>
+              <a:gd name="adj" fmla="val 14286"/>
+            </a:avLst>
+          </a:prstGeom>
+          <a:solidFill>
+            <a:srgbClr val="5B8FF9"/>
+          </a:solidFill>
+          <a:ln w="12700">
+            <a:solidFill>
+              <a:srgbClr val="5B8FF9"/>
+            </a:solidFill>
+            <a:prstDash val="solid"/>
+          </a:ln>
+        </p:spPr>
+        <p:txBody>
+          <a:bodyPr/>
+          <a:lstStyle/>
+          <a:p>
+            <a:endParaRPr lang="en-UA"/>
+          </a:p>
+        </p:txBody>
+      </p:sp>
+      <p:sp>
+        <p:nvSpPr>
+          <p:cNvPr id="8" name="Text 6"/>
+          <p:cNvSpPr/>
+          <p:nvPr/>
+        </p:nvSpPr>
+        <p:spPr>
+          <a:xfrm>
+            <a:off x="722376" y="1371600"/>
+            <a:ext cx="566928" cy="320040"/>
+          </a:xfrm>
+          <a:prstGeom prst="rect">
+            <a:avLst/>
+          </a:prstGeom>
+          <a:noFill/>
+          <a:ln/>
+        </p:spPr>
+        <p:txBody>
+          <a:bodyPr wrap="square" lIns="0" tIns="0" rIns="0" bIns="0" rtlCol="0" anchor="ctr"/>
+          <a:lstStyle/>
+          <a:p>
+            <a:pPr marL="0" indent="0" algn="ctr">
+              <a:buNone/>
+            </a:pPr>
+            <a:r>
+              <a:rPr lang="en-US" sz="1300" b="1" dirty="0">
+                <a:solidFill>
+                  <a:srgbClr val="FFFFFF"/>
+                </a:solidFill>
+                <a:latin typeface="Consolas" pitchFamily="34" charset="0"/>
+                <a:ea typeface="Consolas" pitchFamily="34" charset="-122"/>
+                <a:cs typeface="Consolas" pitchFamily="34" charset="-120"/>
+              </a:rPr>
+              <a:t>0</a:t>
+            </a:r>
+            <a:endParaRPr lang="en-US" sz="1300" dirty="0"/>
+          </a:p>
+        </p:txBody>
+      </p:sp>
+      <p:sp>
+        <p:nvSpPr>
+          <p:cNvPr id="9" name="Shape 7"/>
+          <p:cNvSpPr/>
+          <p:nvPr/>
+        </p:nvSpPr>
+        <p:spPr>
+          <a:xfrm>
+            <a:off x="502920" y="1755648"/>
+            <a:ext cx="1115568" cy="566928"/>
+          </a:xfrm>
+          <a:prstGeom prst="rect">
+            <a:avLst/>
+          </a:prstGeom>
+          <a:solidFill>
+            <a:srgbClr val="EEF2FF"/>
+          </a:solidFill>
+          <a:ln w="12700">
+            <a:solidFill>
+              <a:srgbClr val="C5CADF"/>
+            </a:solidFill>
+            <a:prstDash val="solid"/>
+          </a:ln>
+        </p:spPr>
+        <p:txBody>
+          <a:bodyPr/>
+          <a:lstStyle/>
+          <a:p>
+            <a:endParaRPr lang="en-UA"/>
+          </a:p>
+        </p:txBody>
+      </p:sp>
+      <p:sp>
+        <p:nvSpPr>
+          <p:cNvPr id="10" name="Text 8"/>
+          <p:cNvSpPr/>
+          <p:nvPr/>
+        </p:nvSpPr>
+        <p:spPr>
+          <a:xfrm>
+            <a:off x="502920" y="1755648"/>
+            <a:ext cx="1115568" cy="566928"/>
+          </a:xfrm>
+          <a:prstGeom prst="rect">
+            <a:avLst/>
+          </a:prstGeom>
+          <a:noFill/>
+          <a:ln/>
+        </p:spPr>
+        <p:txBody>
+          <a:bodyPr wrap="square" lIns="0" tIns="0" rIns="0" bIns="0" rtlCol="0" anchor="ctr"/>
+          <a:lstStyle/>
+          <a:p>
+            <a:pPr marL="0" indent="0" algn="ctr">
+              <a:buNone/>
+            </a:pPr>
+            <a:r>
+              <a:rPr lang="en-US" sz="2600" b="1" dirty="0">
+                <a:solidFill>
+                  <a:srgbClr val="1A1F36"/>
+                </a:solidFill>
+                <a:latin typeface="Consolas" pitchFamily="34" charset="0"/>
+                <a:ea typeface="Consolas" pitchFamily="34" charset="-122"/>
+                <a:cs typeface="Consolas" pitchFamily="34" charset="-120"/>
+              </a:rPr>
+              <a:t>П</a:t>
+            </a:r>
+            <a:endParaRPr lang="en-US" sz="2600" dirty="0"/>
+          </a:p>
+        </p:txBody>
+      </p:sp>
+      <p:sp>
+        <p:nvSpPr>
+          <p:cNvPr id="11" name="Shape 9"/>
+          <p:cNvSpPr/>
+          <p:nvPr/>
+        </p:nvSpPr>
+        <p:spPr>
+          <a:xfrm>
+            <a:off x="722376" y="2386584"/>
+            <a:ext cx="566928" cy="320040"/>
+          </a:xfrm>
+          <a:prstGeom prst="roundRect">
+            <a:avLst>
+              <a:gd name="adj" fmla="val 14286"/>
+            </a:avLst>
+          </a:prstGeom>
+          <a:solidFill>
+            <a:srgbClr val="E84855"/>
+          </a:solidFill>
+          <a:ln w="12700">
+            <a:solidFill>
+              <a:srgbClr val="E84855"/>
+            </a:solidFill>
+            <a:prstDash val="solid"/>
+          </a:ln>
+        </p:spPr>
+        <p:txBody>
+          <a:bodyPr/>
+          <a:lstStyle/>
+          <a:p>
+            <a:endParaRPr lang="en-UA"/>
+          </a:p>
+        </p:txBody>
+      </p:sp>
+      <p:sp>
+        <p:nvSpPr>
+          <p:cNvPr id="12" name="Text 10"/>
+          <p:cNvSpPr/>
+          <p:nvPr/>
+        </p:nvSpPr>
+        <p:spPr>
+          <a:xfrm>
+            <a:off x="722376" y="2386584"/>
+            <a:ext cx="566928" cy="320040"/>
+          </a:xfrm>
+          <a:prstGeom prst="rect">
+            <a:avLst/>
+          </a:prstGeom>
+          <a:noFill/>
+          <a:ln/>
+        </p:spPr>
+        <p:txBody>
+          <a:bodyPr wrap="square" lIns="0" tIns="0" rIns="0" bIns="0" rtlCol="0" anchor="ctr"/>
+          <a:lstStyle/>
+          <a:p>
+            <a:pPr marL="0" indent="0" algn="ctr">
+              <a:buNone/>
+            </a:pPr>
+            <a:r>
+              <a:rPr lang="en-US" sz="1300" b="1" dirty="0">
+                <a:solidFill>
+                  <a:srgbClr val="FFFFFF"/>
+                </a:solidFill>
+                <a:latin typeface="Consolas" pitchFamily="34" charset="0"/>
+                <a:ea typeface="Consolas" pitchFamily="34" charset="-122"/>
+                <a:cs typeface="Consolas" pitchFamily="34" charset="-120"/>
+              </a:rPr>
+              <a:t>-6</a:t>
+            </a:r>
+            <a:endParaRPr lang="en-US" sz="1300" dirty="0"/>
+          </a:p>
+        </p:txBody>
+      </p:sp>
+      <p:sp>
+        <p:nvSpPr>
+          <p:cNvPr id="13" name="Shape 11"/>
+          <p:cNvSpPr/>
+          <p:nvPr/>
+        </p:nvSpPr>
+        <p:spPr>
+          <a:xfrm>
+            <a:off x="1892808" y="1371600"/>
+            <a:ext cx="566928" cy="320040"/>
+          </a:xfrm>
+          <a:prstGeom prst="roundRect">
+            <a:avLst>
+              <a:gd name="adj" fmla="val 14286"/>
+            </a:avLst>
+          </a:prstGeom>
+          <a:solidFill>
+            <a:srgbClr val="5B8FF9"/>
+          </a:solidFill>
+          <a:ln w="12700">
+            <a:solidFill>
+              <a:srgbClr val="5B8FF9"/>
+            </a:solidFill>
+            <a:prstDash val="solid"/>
+          </a:ln>
+        </p:spPr>
+        <p:txBody>
+          <a:bodyPr/>
+          <a:lstStyle/>
+          <a:p>
+            <a:endParaRPr lang="en-UA"/>
+          </a:p>
+        </p:txBody>
+      </p:sp>
+      <p:sp>
+        <p:nvSpPr>
+          <p:cNvPr id="14" name="Text 12"/>
+          <p:cNvSpPr/>
+          <p:nvPr/>
+        </p:nvSpPr>
+        <p:spPr>
+          <a:xfrm>
+            <a:off x="1892808" y="1371600"/>
+            <a:ext cx="566928" cy="320040"/>
+          </a:xfrm>
+          <a:prstGeom prst="rect">
+            <a:avLst/>
+          </a:prstGeom>
+          <a:noFill/>
+          <a:ln/>
+        </p:spPr>
+        <p:txBody>
+          <a:bodyPr wrap="square" lIns="0" tIns="0" rIns="0" bIns="0" rtlCol="0" anchor="ctr"/>
+          <a:lstStyle/>
+          <a:p>
+            <a:pPr marL="0" indent="0" algn="ctr">
+              <a:buNone/>
+            </a:pPr>
+            <a:r>
+              <a:rPr lang="en-US" sz="1300" b="1" dirty="0">
+                <a:solidFill>
+                  <a:srgbClr val="FFFFFF"/>
+                </a:solidFill>
+                <a:latin typeface="Consolas" pitchFamily="34" charset="0"/>
+                <a:ea typeface="Consolas" pitchFamily="34" charset="-122"/>
+                <a:cs typeface="Consolas" pitchFamily="34" charset="-120"/>
+              </a:rPr>
+              <a:t>1</a:t>
+            </a:r>
+            <a:endParaRPr lang="en-US" sz="1300" dirty="0"/>
+          </a:p>
+        </p:txBody>
+      </p:sp>
+      <p:sp>
+        <p:nvSpPr>
+          <p:cNvPr id="15" name="Shape 13"/>
+          <p:cNvSpPr/>
+          <p:nvPr/>
+        </p:nvSpPr>
+        <p:spPr>
+          <a:xfrm>
+            <a:off x="1673352" y="1755648"/>
+            <a:ext cx="1115568" cy="566928"/>
+          </a:xfrm>
+          <a:prstGeom prst="rect">
+            <a:avLst/>
+          </a:prstGeom>
+          <a:solidFill>
+            <a:srgbClr val="E3F4F0"/>
+          </a:solidFill>
+          <a:ln w="12700">
+            <a:solidFill>
+              <a:srgbClr val="C5CADF"/>
+            </a:solidFill>
+            <a:prstDash val="solid"/>
+          </a:ln>
+        </p:spPr>
+        <p:txBody>
+          <a:bodyPr/>
+          <a:lstStyle/>
+          <a:p>
+            <a:endParaRPr lang="en-UA"/>
+          </a:p>
+        </p:txBody>
+      </p:sp>
+      <p:sp>
+        <p:nvSpPr>
+          <p:cNvPr id="16" name="Text 14"/>
+          <p:cNvSpPr/>
+          <p:nvPr/>
+        </p:nvSpPr>
+        <p:spPr>
+          <a:xfrm>
+            <a:off x="1673352" y="1755648"/>
+            <a:ext cx="1115568" cy="566928"/>
+          </a:xfrm>
+          <a:prstGeom prst="rect">
+            <a:avLst/>
+          </a:prstGeom>
+          <a:noFill/>
+          <a:ln/>
+        </p:spPr>
+        <p:txBody>
+          <a:bodyPr wrap="square" lIns="0" tIns="0" rIns="0" bIns="0" rtlCol="0" anchor="ctr"/>
+          <a:lstStyle/>
+          <a:p>
+            <a:pPr marL="0" indent="0" algn="ctr">
+              <a:buNone/>
+            </a:pPr>
+            <a:r>
+              <a:rPr lang="en-US" sz="2600" b="1" dirty="0">
+                <a:solidFill>
+                  <a:srgbClr val="1A1F36"/>
+                </a:solidFill>
+                <a:latin typeface="Consolas" pitchFamily="34" charset="0"/>
+                <a:ea typeface="Consolas" pitchFamily="34" charset="-122"/>
+                <a:cs typeface="Consolas" pitchFamily="34" charset="-120"/>
+              </a:rPr>
+              <a:t>р</a:t>
+            </a:r>
+            <a:endParaRPr lang="en-US" sz="2600" dirty="0"/>
+          </a:p>
+        </p:txBody>
+      </p:sp>
+      <p:sp>
+        <p:nvSpPr>
+          <p:cNvPr id="17" name="Shape 15"/>
+          <p:cNvSpPr/>
+          <p:nvPr/>
+        </p:nvSpPr>
+        <p:spPr>
+          <a:xfrm>
+            <a:off x="1892808" y="2386584"/>
+            <a:ext cx="566928" cy="320040"/>
+          </a:xfrm>
+          <a:prstGeom prst="roundRect">
+            <a:avLst>
+              <a:gd name="adj" fmla="val 14286"/>
+            </a:avLst>
+          </a:prstGeom>
+          <a:solidFill>
+            <a:srgbClr val="E84855"/>
+          </a:solidFill>
+          <a:ln w="12700">
+            <a:solidFill>
+              <a:srgbClr val="E84855"/>
+            </a:solidFill>
+            <a:prstDash val="solid"/>
+          </a:ln>
+        </p:spPr>
+        <p:txBody>
+          <a:bodyPr/>
+          <a:lstStyle/>
+          <a:p>
+            <a:endParaRPr lang="en-UA"/>
+          </a:p>
+        </p:txBody>
+      </p:sp>
+      <p:sp>
+        <p:nvSpPr>
+          <p:cNvPr id="18" name="Text 16"/>
+          <p:cNvSpPr/>
+          <p:nvPr/>
+        </p:nvSpPr>
+        <p:spPr>
+          <a:xfrm>
+            <a:off x="1892808" y="2386584"/>
+            <a:ext cx="566928" cy="320040"/>
+          </a:xfrm>
+          <a:prstGeom prst="rect">
+            <a:avLst/>
+          </a:prstGeom>
+          <a:noFill/>
+          <a:ln/>
+        </p:spPr>
+        <p:txBody>
+          <a:bodyPr wrap="square" lIns="0" tIns="0" rIns="0" bIns="0" rtlCol="0" anchor="ctr"/>
+          <a:lstStyle/>
+          <a:p>
+            <a:pPr marL="0" indent="0" algn="ctr">
+              <a:buNone/>
+            </a:pPr>
+            <a:r>
+              <a:rPr lang="en-US" sz="1300" b="1" dirty="0">
+                <a:solidFill>
+                  <a:srgbClr val="FFFFFF"/>
+                </a:solidFill>
+                <a:latin typeface="Consolas" pitchFamily="34" charset="0"/>
+                <a:ea typeface="Consolas" pitchFamily="34" charset="-122"/>
+                <a:cs typeface="Consolas" pitchFamily="34" charset="-120"/>
+              </a:rPr>
+              <a:t>-5</a:t>
+            </a:r>
+            <a:endParaRPr lang="en-US" sz="1300" dirty="0"/>
+          </a:p>
+        </p:txBody>
+      </p:sp>
+      <p:sp>
+        <p:nvSpPr>
+          <p:cNvPr id="19" name="Shape 17"/>
+          <p:cNvSpPr/>
+          <p:nvPr/>
+        </p:nvSpPr>
+        <p:spPr>
+          <a:xfrm>
+            <a:off x="3063240" y="1371600"/>
+            <a:ext cx="566928" cy="320040"/>
+          </a:xfrm>
+          <a:prstGeom prst="roundRect">
+            <a:avLst>
+              <a:gd name="adj" fmla="val 14286"/>
+            </a:avLst>
+          </a:prstGeom>
+          <a:solidFill>
+            <a:srgbClr val="5B8FF9"/>
+          </a:solidFill>
+          <a:ln w="12700">
+            <a:solidFill>
+              <a:srgbClr val="5B8FF9"/>
+            </a:solidFill>
+            <a:prstDash val="solid"/>
+          </a:ln>
+        </p:spPr>
+        <p:txBody>
+          <a:bodyPr/>
+          <a:lstStyle/>
+          <a:p>
+            <a:endParaRPr lang="en-UA"/>
+          </a:p>
+        </p:txBody>
+      </p:sp>
+      <p:sp>
+        <p:nvSpPr>
+          <p:cNvPr id="20" name="Text 18"/>
+          <p:cNvSpPr/>
+          <p:nvPr/>
+        </p:nvSpPr>
+        <p:spPr>
+          <a:xfrm>
+            <a:off x="3063240" y="1371600"/>
+            <a:ext cx="566928" cy="320040"/>
+          </a:xfrm>
+          <a:prstGeom prst="rect">
+            <a:avLst/>
+          </a:prstGeom>
+          <a:noFill/>
+          <a:ln/>
+        </p:spPr>
+        <p:txBody>
+          <a:bodyPr wrap="square" lIns="0" tIns="0" rIns="0" bIns="0" rtlCol="0" anchor="ctr"/>
+          <a:lstStyle/>
+          <a:p>
+            <a:pPr marL="0" indent="0" algn="ctr">
+              <a:buNone/>
+            </a:pPr>
+            <a:r>
+              <a:rPr lang="en-US" sz="1300" b="1" dirty="0">
+                <a:solidFill>
+                  <a:srgbClr val="FFFFFF"/>
+                </a:solidFill>
+                <a:latin typeface="Consolas" pitchFamily="34" charset="0"/>
+                <a:ea typeface="Consolas" pitchFamily="34" charset="-122"/>
+                <a:cs typeface="Consolas" pitchFamily="34" charset="-120"/>
+              </a:rPr>
+              <a:t>2</a:t>
+            </a:r>
+            <a:endParaRPr lang="en-US" sz="1300" dirty="0"/>
+          </a:p>
+        </p:txBody>
+      </p:sp>
+      <p:sp>
+        <p:nvSpPr>
+          <p:cNvPr id="21" name="Shape 19"/>
+          <p:cNvSpPr/>
+          <p:nvPr/>
+        </p:nvSpPr>
+        <p:spPr>
+          <a:xfrm>
+            <a:off x="2843784" y="1755648"/>
+            <a:ext cx="1115568" cy="566928"/>
+          </a:xfrm>
+          <a:prstGeom prst="rect">
+            <a:avLst/>
+          </a:prstGeom>
+          <a:solidFill>
+            <a:srgbClr val="EEF2FF"/>
+          </a:solidFill>
+          <a:ln w="12700">
+            <a:solidFill>
+              <a:srgbClr val="C5CADF"/>
+            </a:solidFill>
+            <a:prstDash val="solid"/>
+          </a:ln>
+        </p:spPr>
+        <p:txBody>
+          <a:bodyPr/>
+          <a:lstStyle/>
+          <a:p>
+            <a:endParaRPr lang="en-UA"/>
+          </a:p>
+        </p:txBody>
+      </p:sp>
+      <p:sp>
+        <p:nvSpPr>
+          <p:cNvPr id="22" name="Text 20"/>
+          <p:cNvSpPr/>
+          <p:nvPr/>
+        </p:nvSpPr>
+        <p:spPr>
+          <a:xfrm>
+            <a:off x="2843784" y="1755648"/>
+            <a:ext cx="1115568" cy="566928"/>
+          </a:xfrm>
+          <a:prstGeom prst="rect">
+            <a:avLst/>
+          </a:prstGeom>
+          <a:noFill/>
+          <a:ln/>
+        </p:spPr>
+        <p:txBody>
+          <a:bodyPr wrap="square" lIns="0" tIns="0" rIns="0" bIns="0" rtlCol="0" anchor="ctr"/>
+          <a:lstStyle/>
+          <a:p>
+            <a:pPr marL="0" indent="0" algn="ctr">
+              <a:buNone/>
+            </a:pPr>
+            <a:r>
+              <a:rPr lang="en-US" sz="2600" b="1" dirty="0">
+                <a:solidFill>
+                  <a:srgbClr val="1A1F36"/>
+                </a:solidFill>
+                <a:latin typeface="Consolas" pitchFamily="34" charset="0"/>
+                <a:ea typeface="Consolas" pitchFamily="34" charset="-122"/>
+                <a:cs typeface="Consolas" pitchFamily="34" charset="-120"/>
+              </a:rPr>
+              <a:t>и</a:t>
+            </a:r>
+            <a:endParaRPr lang="en-US" sz="2600" dirty="0"/>
+          </a:p>
+        </p:txBody>
+      </p:sp>
+      <p:sp>
+        <p:nvSpPr>
+          <p:cNvPr id="23" name="Shape 21"/>
+          <p:cNvSpPr/>
+          <p:nvPr/>
+        </p:nvSpPr>
+        <p:spPr>
+          <a:xfrm>
+            <a:off x="3063240" y="2386584"/>
+            <a:ext cx="566928" cy="320040"/>
+          </a:xfrm>
+          <a:prstGeom prst="roundRect">
+            <a:avLst>
+              <a:gd name="adj" fmla="val 14286"/>
+            </a:avLst>
+          </a:prstGeom>
+          <a:solidFill>
+            <a:srgbClr val="E84855"/>
+          </a:solidFill>
+          <a:ln w="12700">
+            <a:solidFill>
+              <a:srgbClr val="E84855"/>
+            </a:solidFill>
+            <a:prstDash val="solid"/>
+          </a:ln>
+        </p:spPr>
+        <p:txBody>
+          <a:bodyPr/>
+          <a:lstStyle/>
+          <a:p>
+            <a:endParaRPr lang="en-UA"/>
+          </a:p>
+        </p:txBody>
+      </p:sp>
+      <p:sp>
+        <p:nvSpPr>
+          <p:cNvPr id="24" name="Text 22"/>
+          <p:cNvSpPr/>
+          <p:nvPr/>
+        </p:nvSpPr>
+        <p:spPr>
+          <a:xfrm>
+            <a:off x="3063240" y="2386584"/>
+            <a:ext cx="566928" cy="320040"/>
+          </a:xfrm>
+          <a:prstGeom prst="rect">
+            <a:avLst/>
+          </a:prstGeom>
+          <a:noFill/>
+          <a:ln/>
+        </p:spPr>
+        <p:txBody>
+          <a:bodyPr wrap="square" lIns="0" tIns="0" rIns="0" bIns="0" rtlCol="0" anchor="ctr"/>
+          <a:lstStyle/>
+          <a:p>
+            <a:pPr marL="0" indent="0" algn="ctr">
+              <a:buNone/>
+            </a:pPr>
+            <a:r>
+              <a:rPr lang="en-US" sz="1300" b="1" dirty="0">
+                <a:solidFill>
+                  <a:srgbClr val="FFFFFF"/>
+                </a:solidFill>
+                <a:latin typeface="Consolas" pitchFamily="34" charset="0"/>
+                <a:ea typeface="Consolas" pitchFamily="34" charset="-122"/>
+                <a:cs typeface="Consolas" pitchFamily="34" charset="-120"/>
+              </a:rPr>
+              <a:t>-4</a:t>
+            </a:r>
+            <a:endParaRPr lang="en-US" sz="1300" dirty="0"/>
+          </a:p>
+        </p:txBody>
+      </p:sp>
+      <p:sp>
+        <p:nvSpPr>
+          <p:cNvPr id="25" name="Shape 23"/>
+          <p:cNvSpPr/>
+          <p:nvPr/>
+        </p:nvSpPr>
+        <p:spPr>
+          <a:xfrm>
+            <a:off x="4233672" y="1371600"/>
+            <a:ext cx="566928" cy="320040"/>
+          </a:xfrm>
+          <a:prstGeom prst="roundRect">
+            <a:avLst>
+              <a:gd name="adj" fmla="val 14286"/>
+            </a:avLst>
+          </a:prstGeom>
+          <a:solidFill>
+            <a:srgbClr val="5B8FF9"/>
+          </a:solidFill>
+          <a:ln w="12700">
+            <a:solidFill>
+              <a:srgbClr val="5B8FF9"/>
+            </a:solidFill>
+            <a:prstDash val="solid"/>
+          </a:ln>
+        </p:spPr>
+        <p:txBody>
+          <a:bodyPr/>
+          <a:lstStyle/>
+          <a:p>
+            <a:endParaRPr lang="en-UA"/>
+          </a:p>
+        </p:txBody>
+      </p:sp>
+      <p:sp>
+        <p:nvSpPr>
+          <p:cNvPr id="26" name="Text 24"/>
+          <p:cNvSpPr/>
+          <p:nvPr/>
+        </p:nvSpPr>
+        <p:spPr>
+          <a:xfrm>
+            <a:off x="4233672" y="1371600"/>
+            <a:ext cx="566928" cy="320040"/>
+          </a:xfrm>
+          <a:prstGeom prst="rect">
+            <a:avLst/>
+          </a:prstGeom>
+          <a:noFill/>
+          <a:ln/>
+        </p:spPr>
+        <p:txBody>
+          <a:bodyPr wrap="square" lIns="0" tIns="0" rIns="0" bIns="0" rtlCol="0" anchor="ctr"/>
+          <a:lstStyle/>
+          <a:p>
+            <a:pPr marL="0" indent="0" algn="ctr">
+              <a:buNone/>
+            </a:pPr>
+            <a:r>
+              <a:rPr lang="en-US" sz="1300" b="1" dirty="0">
+                <a:solidFill>
+                  <a:srgbClr val="FFFFFF"/>
+                </a:solidFill>
+                <a:latin typeface="Consolas" pitchFamily="34" charset="0"/>
+                <a:ea typeface="Consolas" pitchFamily="34" charset="-122"/>
+                <a:cs typeface="Consolas" pitchFamily="34" charset="-120"/>
+              </a:rPr>
+              <a:t>3</a:t>
+            </a:r>
+            <a:endParaRPr lang="en-US" sz="1300" dirty="0"/>
+          </a:p>
+        </p:txBody>
+      </p:sp>
+      <p:sp>
+        <p:nvSpPr>
+          <p:cNvPr id="27" name="Shape 25"/>
+          <p:cNvSpPr/>
+          <p:nvPr/>
+        </p:nvSpPr>
+        <p:spPr>
+          <a:xfrm>
+            <a:off x="4014216" y="1755648"/>
+            <a:ext cx="1115568" cy="566928"/>
+          </a:xfrm>
+          <a:prstGeom prst="rect">
+            <a:avLst/>
+          </a:prstGeom>
+          <a:solidFill>
+            <a:srgbClr val="E3F4F0"/>
+          </a:solidFill>
+          <a:ln w="12700">
+            <a:solidFill>
+              <a:srgbClr val="C5CADF"/>
+            </a:solidFill>
+            <a:prstDash val="solid"/>
+          </a:ln>
+        </p:spPr>
+        <p:txBody>
+          <a:bodyPr/>
+          <a:lstStyle/>
+          <a:p>
+            <a:endParaRPr lang="en-UA"/>
+          </a:p>
+        </p:txBody>
+      </p:sp>
+      <p:sp>
+        <p:nvSpPr>
+          <p:cNvPr id="28" name="Text 26"/>
+          <p:cNvSpPr/>
+          <p:nvPr/>
+        </p:nvSpPr>
+        <p:spPr>
+          <a:xfrm>
+            <a:off x="4014216" y="1755648"/>
+            <a:ext cx="1115568" cy="566928"/>
+          </a:xfrm>
+          <a:prstGeom prst="rect">
+            <a:avLst/>
+          </a:prstGeom>
+          <a:noFill/>
+          <a:ln/>
+        </p:spPr>
+        <p:txBody>
+          <a:bodyPr wrap="square" lIns="0" tIns="0" rIns="0" bIns="0" rtlCol="0" anchor="ctr"/>
+          <a:lstStyle/>
+          <a:p>
+            <a:pPr marL="0" indent="0" algn="ctr">
+              <a:buNone/>
+            </a:pPr>
+            <a:r>
+              <a:rPr lang="en-US" sz="2600" b="1" dirty="0">
+                <a:solidFill>
+                  <a:srgbClr val="1A1F36"/>
+                </a:solidFill>
+                <a:latin typeface="Consolas" pitchFamily="34" charset="0"/>
+                <a:ea typeface="Consolas" pitchFamily="34" charset="-122"/>
+                <a:cs typeface="Consolas" pitchFamily="34" charset="-120"/>
+              </a:rPr>
+              <a:t>в</a:t>
+            </a:r>
+            <a:endParaRPr lang="en-US" sz="2600" dirty="0"/>
+          </a:p>
+        </p:txBody>
+      </p:sp>
+      <p:sp>
+        <p:nvSpPr>
+          <p:cNvPr id="29" name="Shape 27"/>
+          <p:cNvSpPr/>
+          <p:nvPr/>
+        </p:nvSpPr>
+        <p:spPr>
+          <a:xfrm>
+            <a:off x="4233672" y="2386584"/>
+            <a:ext cx="566928" cy="320040"/>
+          </a:xfrm>
+          <a:prstGeom prst="roundRect">
+            <a:avLst>
+              <a:gd name="adj" fmla="val 14286"/>
+            </a:avLst>
+          </a:prstGeom>
+          <a:solidFill>
+            <a:srgbClr val="E84855"/>
+          </a:solidFill>
+          <a:ln w="12700">
+            <a:solidFill>
+              <a:srgbClr val="E84855"/>
+            </a:solidFill>
+            <a:prstDash val="solid"/>
+          </a:ln>
+        </p:spPr>
+        <p:txBody>
+          <a:bodyPr/>
+          <a:lstStyle/>
+          <a:p>
+            <a:endParaRPr lang="en-UA"/>
+          </a:p>
+        </p:txBody>
+      </p:sp>
+      <p:sp>
+        <p:nvSpPr>
+          <p:cNvPr id="30" name="Text 28"/>
+          <p:cNvSpPr/>
+          <p:nvPr/>
+        </p:nvSpPr>
+        <p:spPr>
+          <a:xfrm>
+            <a:off x="4233672" y="2386584"/>
+            <a:ext cx="566928" cy="320040"/>
+          </a:xfrm>
+          <a:prstGeom prst="rect">
+            <a:avLst/>
+          </a:prstGeom>
+          <a:noFill/>
+          <a:ln/>
+        </p:spPr>
+        <p:txBody>
+          <a:bodyPr wrap="square" lIns="0" tIns="0" rIns="0" bIns="0" rtlCol="0" anchor="ctr"/>
+          <a:lstStyle/>
+          <a:p>
+            <a:pPr marL="0" indent="0" algn="ctr">
+              <a:buNone/>
+            </a:pPr>
+            <a:r>
+              <a:rPr lang="en-US" sz="1300" b="1" dirty="0">
+                <a:solidFill>
+                  <a:srgbClr val="FFFFFF"/>
+                </a:solidFill>
+                <a:latin typeface="Consolas" pitchFamily="34" charset="0"/>
+                <a:ea typeface="Consolas" pitchFamily="34" charset="-122"/>
+                <a:cs typeface="Consolas" pitchFamily="34" charset="-120"/>
+              </a:rPr>
+              <a:t>-3</a:t>
+            </a:r>
+            <a:endParaRPr lang="en-US" sz="1300" dirty="0"/>
+          </a:p>
+        </p:txBody>
+      </p:sp>
+      <p:sp>
+        <p:nvSpPr>
+          <p:cNvPr id="31" name="Shape 29"/>
+          <p:cNvSpPr/>
+          <p:nvPr/>
+        </p:nvSpPr>
+        <p:spPr>
+          <a:xfrm>
+            <a:off x="5404104" y="1371600"/>
+            <a:ext cx="566928" cy="320040"/>
+          </a:xfrm>
+          <a:prstGeom prst="roundRect">
+            <a:avLst>
+              <a:gd name="adj" fmla="val 14286"/>
+            </a:avLst>
+          </a:prstGeom>
+          <a:solidFill>
+            <a:srgbClr val="5B8FF9"/>
+          </a:solidFill>
+          <a:ln w="12700">
+            <a:solidFill>
+              <a:srgbClr val="5B8FF9"/>
+            </a:solidFill>
+            <a:prstDash val="solid"/>
+          </a:ln>
+        </p:spPr>
+        <p:txBody>
+          <a:bodyPr/>
+          <a:lstStyle/>
+          <a:p>
+            <a:endParaRPr lang="en-UA"/>
+          </a:p>
+        </p:txBody>
+      </p:sp>
+      <p:sp>
+        <p:nvSpPr>
+          <p:cNvPr id="32" name="Text 30"/>
+          <p:cNvSpPr/>
+          <p:nvPr/>
+        </p:nvSpPr>
+        <p:spPr>
+          <a:xfrm>
+            <a:off x="5404104" y="1371600"/>
+            <a:ext cx="566928" cy="320040"/>
+          </a:xfrm>
+          <a:prstGeom prst="rect">
+            <a:avLst/>
+          </a:prstGeom>
+          <a:noFill/>
+          <a:ln/>
+        </p:spPr>
+        <p:txBody>
+          <a:bodyPr wrap="square" lIns="0" tIns="0" rIns="0" bIns="0" rtlCol="0" anchor="ctr"/>
+          <a:lstStyle/>
+          <a:p>
+            <a:pPr marL="0" indent="0" algn="ctr">
+              <a:buNone/>
+            </a:pPr>
+            <a:r>
+              <a:rPr lang="en-US" sz="1300" b="1" dirty="0">
+                <a:solidFill>
+                  <a:srgbClr val="FFFFFF"/>
+                </a:solidFill>
+                <a:latin typeface="Consolas" pitchFamily="34" charset="0"/>
+                <a:ea typeface="Consolas" pitchFamily="34" charset="-122"/>
+                <a:cs typeface="Consolas" pitchFamily="34" charset="-120"/>
+              </a:rPr>
+              <a:t>4</a:t>
+            </a:r>
+            <a:endParaRPr lang="en-US" sz="1300" dirty="0"/>
+          </a:p>
+        </p:txBody>
+      </p:sp>
+      <p:sp>
+        <p:nvSpPr>
+          <p:cNvPr id="33" name="Shape 31"/>
+          <p:cNvSpPr/>
+          <p:nvPr/>
+        </p:nvSpPr>
+        <p:spPr>
+          <a:xfrm>
+            <a:off x="5184648" y="1755648"/>
+            <a:ext cx="1115568" cy="566928"/>
+          </a:xfrm>
+          <a:prstGeom prst="rect">
+            <a:avLst/>
+          </a:prstGeom>
+          <a:solidFill>
+            <a:srgbClr val="EEF2FF"/>
+          </a:solidFill>
+          <a:ln w="12700">
+            <a:solidFill>
+              <a:srgbClr val="C5CADF"/>
+            </a:solidFill>
+            <a:prstDash val="solid"/>
+          </a:ln>
+        </p:spPr>
+        <p:txBody>
+          <a:bodyPr/>
+          <a:lstStyle/>
+          <a:p>
+            <a:endParaRPr lang="en-UA"/>
+          </a:p>
+        </p:txBody>
+      </p:sp>
+      <p:sp>
+        <p:nvSpPr>
+          <p:cNvPr id="34" name="Text 32"/>
+          <p:cNvSpPr/>
+          <p:nvPr/>
+        </p:nvSpPr>
+        <p:spPr>
+          <a:xfrm>
+            <a:off x="5184648" y="1755648"/>
+            <a:ext cx="1115568" cy="566928"/>
+          </a:xfrm>
+          <a:prstGeom prst="rect">
+            <a:avLst/>
+          </a:prstGeom>
+          <a:noFill/>
+          <a:ln/>
+        </p:spPr>
+        <p:txBody>
+          <a:bodyPr wrap="square" lIns="0" tIns="0" rIns="0" bIns="0" rtlCol="0" anchor="ctr"/>
+          <a:lstStyle/>
+          <a:p>
+            <a:pPr marL="0" indent="0" algn="ctr">
+              <a:buNone/>
+            </a:pPr>
+            <a:r>
+              <a:rPr lang="en-US" sz="2600" b="1" dirty="0">
+                <a:solidFill>
+                  <a:srgbClr val="1A1F36"/>
+                </a:solidFill>
+                <a:latin typeface="Consolas" pitchFamily="34" charset="0"/>
+                <a:ea typeface="Consolas" pitchFamily="34" charset="-122"/>
+                <a:cs typeface="Consolas" pitchFamily="34" charset="-120"/>
+              </a:rPr>
+              <a:t>і</a:t>
+            </a:r>
+            <a:endParaRPr lang="en-US" sz="2600" dirty="0"/>
+          </a:p>
+        </p:txBody>
+      </p:sp>
+      <p:sp>
+        <p:nvSpPr>
+          <p:cNvPr id="35" name="Shape 33"/>
+          <p:cNvSpPr/>
+          <p:nvPr/>
+        </p:nvSpPr>
+        <p:spPr>
+          <a:xfrm>
+            <a:off x="5404104" y="2386584"/>
+            <a:ext cx="566928" cy="320040"/>
+          </a:xfrm>
+          <a:prstGeom prst="roundRect">
+            <a:avLst>
+              <a:gd name="adj" fmla="val 14286"/>
+            </a:avLst>
+          </a:prstGeom>
+          <a:solidFill>
+            <a:srgbClr val="E84855"/>
+          </a:solidFill>
+          <a:ln w="12700">
+            <a:solidFill>
+              <a:srgbClr val="E84855"/>
+            </a:solidFill>
+            <a:prstDash val="solid"/>
+          </a:ln>
+        </p:spPr>
+        <p:txBody>
+          <a:bodyPr/>
+          <a:lstStyle/>
+          <a:p>
+            <a:endParaRPr lang="en-UA"/>
+          </a:p>
+        </p:txBody>
+      </p:sp>
+      <p:sp>
+        <p:nvSpPr>
+          <p:cNvPr id="36" name="Text 34"/>
+          <p:cNvSpPr/>
+          <p:nvPr/>
+        </p:nvSpPr>
+        <p:spPr>
+          <a:xfrm>
+            <a:off x="5404104" y="2386584"/>
+            <a:ext cx="566928" cy="320040"/>
+          </a:xfrm>
+          <a:prstGeom prst="rect">
+            <a:avLst/>
+          </a:prstGeom>
+          <a:noFill/>
+          <a:ln/>
+        </p:spPr>
+        <p:txBody>
+          <a:bodyPr wrap="square" lIns="0" tIns="0" rIns="0" bIns="0" rtlCol="0" anchor="ctr"/>
+          <a:lstStyle/>
+          <a:p>
+            <a:pPr marL="0" indent="0" algn="ctr">
+              <a:buNone/>
+            </a:pPr>
+            <a:r>
+              <a:rPr lang="en-US" sz="1300" b="1" dirty="0">
+                <a:solidFill>
+                  <a:srgbClr val="FFFFFF"/>
+                </a:solidFill>
+                <a:latin typeface="Consolas" pitchFamily="34" charset="0"/>
+                <a:ea typeface="Consolas" pitchFamily="34" charset="-122"/>
+                <a:cs typeface="Consolas" pitchFamily="34" charset="-120"/>
+              </a:rPr>
+              <a:t>-2</a:t>
+            </a:r>
+            <a:endParaRPr lang="en-US" sz="1300" dirty="0"/>
+          </a:p>
+        </p:txBody>
+      </p:sp>
+      <p:sp>
+        <p:nvSpPr>
+          <p:cNvPr id="37" name="Shape 35"/>
+          <p:cNvSpPr/>
+          <p:nvPr/>
+        </p:nvSpPr>
+        <p:spPr>
+          <a:xfrm>
+            <a:off x="6574536" y="1371600"/>
+            <a:ext cx="566928" cy="320040"/>
+          </a:xfrm>
+          <a:prstGeom prst="roundRect">
+            <a:avLst>
+              <a:gd name="adj" fmla="val 14286"/>
+            </a:avLst>
+          </a:prstGeom>
+          <a:solidFill>
+            <a:srgbClr val="5B8FF9"/>
+          </a:solidFill>
+          <a:ln w="12700">
+            <a:solidFill>
+              <a:srgbClr val="5B8FF9"/>
+            </a:solidFill>
+            <a:prstDash val="solid"/>
+          </a:ln>
+        </p:spPr>
+        <p:txBody>
+          <a:bodyPr/>
+          <a:lstStyle/>
+          <a:p>
+            <a:endParaRPr lang="en-UA"/>
+          </a:p>
+        </p:txBody>
+      </p:sp>
+      <p:sp>
+        <p:nvSpPr>
+          <p:cNvPr id="38" name="Text 36"/>
+          <p:cNvSpPr/>
+          <p:nvPr/>
+        </p:nvSpPr>
+        <p:spPr>
+          <a:xfrm>
+            <a:off x="6574536" y="1371600"/>
+            <a:ext cx="566928" cy="320040"/>
+          </a:xfrm>
+          <a:prstGeom prst="rect">
+            <a:avLst/>
+          </a:prstGeom>
+          <a:noFill/>
+          <a:ln/>
+        </p:spPr>
+        <p:txBody>
+          <a:bodyPr wrap="square" lIns="0" tIns="0" rIns="0" bIns="0" rtlCol="0" anchor="ctr"/>
+          <a:lstStyle/>
+          <a:p>
+            <a:pPr marL="0" indent="0" algn="ctr">
+              <a:buNone/>
+            </a:pPr>
+            <a:r>
+              <a:rPr lang="en-US" sz="1300" b="1" dirty="0">
+                <a:solidFill>
+                  <a:srgbClr val="FFFFFF"/>
+                </a:solidFill>
+                <a:latin typeface="Consolas" pitchFamily="34" charset="0"/>
+                <a:ea typeface="Consolas" pitchFamily="34" charset="-122"/>
+                <a:cs typeface="Consolas" pitchFamily="34" charset="-120"/>
+              </a:rPr>
+              <a:t>5</a:t>
+            </a:r>
+            <a:endParaRPr lang="en-US" sz="1300" dirty="0"/>
+          </a:p>
+        </p:txBody>
+      </p:sp>
+      <p:sp>
+        <p:nvSpPr>
+          <p:cNvPr id="39" name="Shape 37"/>
+          <p:cNvSpPr/>
+          <p:nvPr/>
+        </p:nvSpPr>
+        <p:spPr>
+          <a:xfrm>
+            <a:off x="6355080" y="1755648"/>
+            <a:ext cx="1115568" cy="566928"/>
+          </a:xfrm>
+          <a:prstGeom prst="rect">
+            <a:avLst/>
+          </a:prstGeom>
+          <a:solidFill>
+            <a:srgbClr val="E3F4F0"/>
+          </a:solidFill>
+          <a:ln w="12700">
+            <a:solidFill>
+              <a:srgbClr val="C5CADF"/>
+            </a:solidFill>
+            <a:prstDash val="solid"/>
+          </a:ln>
+        </p:spPr>
+        <p:txBody>
+          <a:bodyPr/>
+          <a:lstStyle/>
+          <a:p>
+            <a:endParaRPr lang="en-UA"/>
+          </a:p>
+        </p:txBody>
+      </p:sp>
+      <p:sp>
+        <p:nvSpPr>
+          <p:cNvPr id="40" name="Text 38"/>
+          <p:cNvSpPr/>
+          <p:nvPr/>
+        </p:nvSpPr>
+        <p:spPr>
+          <a:xfrm>
+            <a:off x="6355080" y="1755648"/>
+            <a:ext cx="1115568" cy="566928"/>
+          </a:xfrm>
+          <a:prstGeom prst="rect">
+            <a:avLst/>
+          </a:prstGeom>
+          <a:noFill/>
+          <a:ln/>
+        </p:spPr>
+        <p:txBody>
+          <a:bodyPr wrap="square" lIns="0" tIns="0" rIns="0" bIns="0" rtlCol="0" anchor="ctr"/>
+          <a:lstStyle/>
+          <a:p>
+            <a:pPr marL="0" indent="0" algn="ctr">
+              <a:buNone/>
+            </a:pPr>
+            <a:r>
+              <a:rPr lang="en-US" sz="2600" b="1" dirty="0">
+                <a:solidFill>
+                  <a:srgbClr val="1A1F36"/>
+                </a:solidFill>
+                <a:latin typeface="Consolas" pitchFamily="34" charset="0"/>
+                <a:ea typeface="Consolas" pitchFamily="34" charset="-122"/>
+                <a:cs typeface="Consolas" pitchFamily="34" charset="-120"/>
+              </a:rPr>
+              <a:t>т</a:t>
+            </a:r>
+            <a:endParaRPr lang="en-US" sz="2600" dirty="0"/>
+          </a:p>
+        </p:txBody>
+      </p:sp>
+      <p:sp>
+        <p:nvSpPr>
+          <p:cNvPr id="41" name="Shape 39"/>
+          <p:cNvSpPr/>
+          <p:nvPr/>
+        </p:nvSpPr>
+        <p:spPr>
+          <a:xfrm>
+            <a:off x="6574536" y="2386584"/>
+            <a:ext cx="566928" cy="320040"/>
+          </a:xfrm>
+          <a:prstGeom prst="roundRect">
+            <a:avLst>
+              <a:gd name="adj" fmla="val 14286"/>
+            </a:avLst>
+          </a:prstGeom>
+          <a:solidFill>
+            <a:srgbClr val="E84855"/>
+          </a:solidFill>
+          <a:ln w="12700">
+            <a:solidFill>
+              <a:srgbClr val="E84855"/>
+            </a:solidFill>
+            <a:prstDash val="solid"/>
+          </a:ln>
+        </p:spPr>
+        <p:txBody>
+          <a:bodyPr/>
+          <a:lstStyle/>
+          <a:p>
+            <a:endParaRPr lang="en-UA"/>
+          </a:p>
+        </p:txBody>
+      </p:sp>
+      <p:sp>
+        <p:nvSpPr>
+          <p:cNvPr id="42" name="Text 40"/>
+          <p:cNvSpPr/>
+          <p:nvPr/>
+        </p:nvSpPr>
+        <p:spPr>
+          <a:xfrm>
+            <a:off x="6574536" y="2386584"/>
+            <a:ext cx="566928" cy="320040"/>
+          </a:xfrm>
+          <a:prstGeom prst="rect">
+            <a:avLst/>
+          </a:prstGeom>
+          <a:noFill/>
+          <a:ln/>
+        </p:spPr>
+        <p:txBody>
+          <a:bodyPr wrap="square" lIns="0" tIns="0" rIns="0" bIns="0" rtlCol="0" anchor="ctr"/>
+          <a:lstStyle/>
+          <a:p>
+            <a:pPr marL="0" indent="0" algn="ctr">
+              <a:buNone/>
+            </a:pPr>
+            <a:r>
+              <a:rPr lang="en-US" sz="1300" b="1" dirty="0">
+                <a:solidFill>
+                  <a:srgbClr val="FFFFFF"/>
+                </a:solidFill>
+                <a:latin typeface="Consolas" pitchFamily="34" charset="0"/>
+                <a:ea typeface="Consolas" pitchFamily="34" charset="-122"/>
+                <a:cs typeface="Consolas" pitchFamily="34" charset="-120"/>
+              </a:rPr>
+              <a:t>-1</a:t>
+            </a:r>
+            <a:endParaRPr lang="en-US" sz="1300" dirty="0"/>
+          </a:p>
+        </p:txBody>
+      </p:sp>
+      <p:sp>
+        <p:nvSpPr>
+          <p:cNvPr id="43" name="Shape 41"/>
+          <p:cNvSpPr/>
+          <p:nvPr/>
+        </p:nvSpPr>
+        <p:spPr>
+          <a:xfrm>
+            <a:off x="7598664" y="1353312"/>
+            <a:ext cx="566928" cy="320040"/>
+          </a:xfrm>
+          <a:prstGeom prst="ellipse">
+            <a:avLst/>
+          </a:prstGeom>
+          <a:solidFill>
+            <a:srgbClr val="5B8FF9"/>
+          </a:solidFill>
+          <a:ln w="12700">
+            <a:solidFill>
+              <a:srgbClr val="5B8FF9"/>
+            </a:solidFill>
+            <a:prstDash val="solid"/>
+          </a:ln>
+        </p:spPr>
+        <p:txBody>
+          <a:bodyPr/>
+          <a:lstStyle/>
+          <a:p>
+            <a:endParaRPr lang="en-UA"/>
+          </a:p>
+        </p:txBody>
+      </p:sp>
+      <p:sp>
+        <p:nvSpPr>
+          <p:cNvPr id="44" name="Text 42"/>
+          <p:cNvSpPr/>
+          <p:nvPr/>
+        </p:nvSpPr>
+        <p:spPr>
+          <a:xfrm>
+            <a:off x="7598664" y="1353312"/>
+            <a:ext cx="566928" cy="320040"/>
+          </a:xfrm>
+          <a:prstGeom prst="rect">
+            <a:avLst/>
+          </a:prstGeom>
+          <a:noFill/>
+          <a:ln/>
+        </p:spPr>
+        <p:txBody>
+          <a:bodyPr wrap="square" lIns="0" tIns="0" rIns="0" bIns="0" rtlCol="0" anchor="ctr"/>
+          <a:lstStyle/>
+          <a:p>
+            <a:pPr marL="0" indent="0" algn="ctr">
+              <a:buNone/>
+            </a:pPr>
+            <a:r>
+              <a:rPr lang="en-US" sz="1400" b="1" dirty="0">
+                <a:solidFill>
+                  <a:srgbClr val="FFFFFF"/>
+                </a:solidFill>
+                <a:latin typeface="Calibri" pitchFamily="34" charset="0"/>
+                <a:ea typeface="Calibri" pitchFamily="34" charset="-122"/>
+                <a:cs typeface="Calibri" pitchFamily="34" charset="-120"/>
+              </a:rPr>
+              <a:t>+ </a:t>
+            </a:r>
+            <a:endParaRPr lang="en-US" sz="1400" dirty="0"/>
+          </a:p>
+        </p:txBody>
+      </p:sp>
+      <p:sp>
+        <p:nvSpPr>
+          <p:cNvPr id="45" name="Shape 43"/>
+          <p:cNvSpPr/>
+          <p:nvPr/>
+        </p:nvSpPr>
+        <p:spPr>
+          <a:xfrm>
+            <a:off x="7598664" y="2386584"/>
+            <a:ext cx="566928" cy="320040"/>
+          </a:xfrm>
+          <a:prstGeom prst="ellipse">
+            <a:avLst/>
+          </a:prstGeom>
+          <a:solidFill>
+            <a:srgbClr val="E84855"/>
+          </a:solidFill>
+          <a:ln w="12700">
+            <a:solidFill>
+              <a:srgbClr val="E84855"/>
+            </a:solidFill>
+            <a:prstDash val="solid"/>
+          </a:ln>
+        </p:spPr>
+        <p:txBody>
+          <a:bodyPr/>
+          <a:lstStyle/>
+          <a:p>
+            <a:endParaRPr lang="en-UA"/>
+          </a:p>
+        </p:txBody>
+      </p:sp>
+      <p:sp>
+        <p:nvSpPr>
+          <p:cNvPr id="46" name="Text 44"/>
+          <p:cNvSpPr/>
+          <p:nvPr/>
+        </p:nvSpPr>
+        <p:spPr>
+          <a:xfrm>
+            <a:off x="7598664" y="2386584"/>
+            <a:ext cx="566928" cy="320040"/>
+          </a:xfrm>
+          <a:prstGeom prst="rect">
+            <a:avLst/>
+          </a:prstGeom>
+          <a:noFill/>
+          <a:ln/>
+        </p:spPr>
+        <p:txBody>
+          <a:bodyPr wrap="square" lIns="0" tIns="0" rIns="0" bIns="0" rtlCol="0" anchor="ctr"/>
+          <a:lstStyle/>
+          <a:p>
+            <a:pPr marL="0" indent="0" algn="ctr">
+              <a:buNone/>
+            </a:pPr>
+            <a:r>
+              <a:rPr lang="en-US" sz="1400" b="1" dirty="0">
+                <a:solidFill>
+                  <a:srgbClr val="FFFFFF"/>
+                </a:solidFill>
+                <a:latin typeface="Calibri" pitchFamily="34" charset="0"/>
+                <a:ea typeface="Calibri" pitchFamily="34" charset="-122"/>
+                <a:cs typeface="Calibri" pitchFamily="34" charset="-120"/>
+              </a:rPr>
+              <a:t>− </a:t>
+            </a:r>
+            <a:endParaRPr lang="en-US" sz="1400" dirty="0"/>
+          </a:p>
+        </p:txBody>
+      </p:sp>
+      <p:sp>
+        <p:nvSpPr>
+          <p:cNvPr id="47" name="Shape 45"/>
+          <p:cNvSpPr/>
+          <p:nvPr/>
+        </p:nvSpPr>
+        <p:spPr>
+          <a:xfrm>
+            <a:off x="457200" y="3401568"/>
+            <a:ext cx="4572000" cy="1600200"/>
+          </a:xfrm>
+          <a:prstGeom prst="rect">
+            <a:avLst/>
+          </a:prstGeom>
+          <a:solidFill>
+            <a:srgbClr val="161B2E"/>
+          </a:solidFill>
+          <a:ln w="12700">
+            <a:solidFill>
+              <a:srgbClr val="2A3358"/>
+            </a:solidFill>
+            <a:prstDash val="solid"/>
+          </a:ln>
+        </p:spPr>
+        <p:txBody>
+          <a:bodyPr/>
+          <a:lstStyle/>
+          <a:p>
+            <a:endParaRPr lang="en-UA"/>
+          </a:p>
+        </p:txBody>
+      </p:sp>
+      <p:sp>
+        <p:nvSpPr>
+          <p:cNvPr id="48" name="Shape 46"/>
+          <p:cNvSpPr/>
+          <p:nvPr/>
+        </p:nvSpPr>
+        <p:spPr>
+          <a:xfrm>
+            <a:off x="621792" y="3520440"/>
+            <a:ext cx="109728" cy="109728"/>
+          </a:xfrm>
+          <a:prstGeom prst="ellipse">
+            <a:avLst/>
+          </a:prstGeom>
+          <a:solidFill>
+            <a:srgbClr val="FF5F57"/>
+          </a:solidFill>
+          <a:ln w="12700">
+            <a:solidFill>
+              <a:srgbClr val="FF5F57"/>
+            </a:solidFill>
+            <a:prstDash val="solid"/>
+          </a:ln>
+        </p:spPr>
+        <p:txBody>
+          <a:bodyPr/>
+          <a:lstStyle/>
+          <a:p>
+            <a:endParaRPr lang="en-UA"/>
+          </a:p>
+        </p:txBody>
+      </p:sp>
+      <p:sp>
+        <p:nvSpPr>
+          <p:cNvPr id="49" name="Shape 47"/>
+          <p:cNvSpPr/>
+          <p:nvPr/>
+        </p:nvSpPr>
+        <p:spPr>
+          <a:xfrm>
+            <a:off x="822960" y="3520440"/>
+            <a:ext cx="109728" cy="109728"/>
+          </a:xfrm>
+          <a:prstGeom prst="ellipse">
+            <a:avLst/>
+          </a:prstGeom>
+          <a:solidFill>
+            <a:srgbClr val="FEBC2E"/>
+          </a:solidFill>
+          <a:ln w="12700">
+            <a:solidFill>
+              <a:srgbClr val="FEBC2E"/>
+            </a:solidFill>
+            <a:prstDash val="solid"/>
+          </a:ln>
+        </p:spPr>
+        <p:txBody>
+          <a:bodyPr/>
+          <a:lstStyle/>
+          <a:p>
+            <a:endParaRPr lang="en-UA"/>
+          </a:p>
+        </p:txBody>
+      </p:sp>
+      <p:sp>
+        <p:nvSpPr>
+          <p:cNvPr id="50" name="Shape 48"/>
+          <p:cNvSpPr/>
+          <p:nvPr/>
+        </p:nvSpPr>
+        <p:spPr>
+          <a:xfrm>
+            <a:off x="1024128" y="3520440"/>
+            <a:ext cx="109728" cy="109728"/>
+          </a:xfrm>
+          <a:prstGeom prst="ellipse">
+            <a:avLst/>
+          </a:prstGeom>
+          <a:solidFill>
+            <a:srgbClr val="28C840"/>
+          </a:solidFill>
+          <a:ln w="12700">
+            <a:solidFill>
+              <a:srgbClr val="28C840"/>
+            </a:solidFill>
+            <a:prstDash val="solid"/>
+          </a:ln>
+        </p:spPr>
+        <p:txBody>
+          <a:bodyPr/>
+          <a:lstStyle/>
+          <a:p>
+            <a:endParaRPr lang="en-UA"/>
+          </a:p>
+        </p:txBody>
+      </p:sp>
+      <p:sp>
+        <p:nvSpPr>
+          <p:cNvPr id="51" name="Text 49"/>
+          <p:cNvSpPr/>
+          <p:nvPr/>
+        </p:nvSpPr>
+        <p:spPr>
+          <a:xfrm>
+            <a:off x="594360" y="3721608"/>
+            <a:ext cx="4297680" cy="1188720"/>
+          </a:xfrm>
+          <a:prstGeom prst="rect">
+            <a:avLst/>
+          </a:prstGeom>
+          <a:noFill/>
+          <a:ln/>
+        </p:spPr>
+        <p:txBody>
+          <a:bodyPr wrap="square" lIns="0" tIns="0" rIns="0" bIns="0" rtlCol="0" anchor="t"/>
+          <a:lstStyle/>
+          <a:p>
+            <a:pPr marL="0" indent="0">
+              <a:buNone/>
+            </a:pPr>
+            <a:r>
+              <a:rPr lang="en-US" sz="1400" dirty="0">
+                <a:solidFill>
+                  <a:srgbClr val="A9D4FF"/>
+                </a:solidFill>
+                <a:latin typeface="Consolas" pitchFamily="34" charset="0"/>
+                <a:ea typeface="Consolas" pitchFamily="34" charset="-122"/>
+                <a:cs typeface="Consolas" pitchFamily="34" charset="-120"/>
+              </a:rPr>
+              <a:t>s</a:t>
+            </a:r>
+            <a:r>
+              <a:rPr lang="en-US" sz="1400" dirty="0">
+                <a:solidFill>
+                  <a:srgbClr val="7A8BB5"/>
+                </a:solidFill>
+                <a:latin typeface="Consolas" pitchFamily="34" charset="0"/>
+                <a:ea typeface="Consolas" pitchFamily="34" charset="-122"/>
+                <a:cs typeface="Consolas" pitchFamily="34" charset="-120"/>
+              </a:rPr>
+              <a:t> = </a:t>
+            </a:r>
+            <a:r>
+              <a:rPr lang="en-US" sz="1400" dirty="0">
+                <a:solidFill>
+                  <a:srgbClr val="6DDC8B"/>
+                </a:solidFill>
+                <a:latin typeface="Consolas" pitchFamily="34" charset="0"/>
+                <a:ea typeface="Consolas" pitchFamily="34" charset="-122"/>
+                <a:cs typeface="Consolas" pitchFamily="34" charset="-120"/>
+              </a:rPr>
+              <a:t>"Привіт"</a:t>
+            </a:r>
+            <a:endParaRPr lang="en-US" sz="1400" dirty="0"/>
+          </a:p>
+          <a:p>
+            <a:pPr marL="0" indent="0">
+              <a:buNone/>
+            </a:pPr>
+            <a:endParaRPr lang="en-US" sz="1400" dirty="0"/>
+          </a:p>
+          <a:p>
+            <a:pPr marL="0" indent="0">
+              <a:buNone/>
+            </a:pPr>
+            <a:r>
+              <a:rPr lang="en-US" sz="1400" dirty="0">
+                <a:solidFill>
+                  <a:srgbClr val="FF9D6C"/>
+                </a:solidFill>
+                <a:latin typeface="Consolas" pitchFamily="34" charset="0"/>
+                <a:ea typeface="Consolas" pitchFamily="34" charset="-122"/>
+                <a:cs typeface="Consolas" pitchFamily="34" charset="-120"/>
+              </a:rPr>
+              <a:t>print</a:t>
+            </a:r>
+            <a:r>
+              <a:rPr lang="en-US" sz="1400" dirty="0">
+                <a:solidFill>
+                  <a:srgbClr val="A9D4FF"/>
+                </a:solidFill>
+                <a:latin typeface="Consolas" pitchFamily="34" charset="0"/>
+                <a:ea typeface="Consolas" pitchFamily="34" charset="-122"/>
+                <a:cs typeface="Consolas" pitchFamily="34" charset="-120"/>
+              </a:rPr>
+              <a:t>(s[</a:t>
+            </a:r>
+            <a:r>
+              <a:rPr lang="en-US" sz="1400" dirty="0">
+                <a:solidFill>
+                  <a:srgbClr val="C9A0FF"/>
+                </a:solidFill>
+                <a:latin typeface="Consolas" pitchFamily="34" charset="0"/>
+                <a:ea typeface="Consolas" pitchFamily="34" charset="-122"/>
+                <a:cs typeface="Consolas" pitchFamily="34" charset="-120"/>
+              </a:rPr>
+              <a:t>0</a:t>
+            </a:r>
+            <a:r>
+              <a:rPr lang="en-US" sz="1400" dirty="0">
+                <a:solidFill>
+                  <a:srgbClr val="A9D4FF"/>
+                </a:solidFill>
+                <a:latin typeface="Consolas" pitchFamily="34" charset="0"/>
+                <a:ea typeface="Consolas" pitchFamily="34" charset="-122"/>
+                <a:cs typeface="Consolas" pitchFamily="34" charset="-120"/>
+              </a:rPr>
+              <a:t>])</a:t>
+            </a:r>
+            <a:r>
+              <a:rPr lang="en-US" sz="1400" dirty="0">
+                <a:solidFill>
+                  <a:srgbClr val="7A8BB5"/>
+                </a:solidFill>
+                <a:latin typeface="Consolas" pitchFamily="34" charset="0"/>
+                <a:ea typeface="Consolas" pitchFamily="34" charset="-122"/>
+                <a:cs typeface="Consolas" pitchFamily="34" charset="-120"/>
+              </a:rPr>
+              <a:t>   # "П"</a:t>
+            </a:r>
+            <a:endParaRPr lang="en-US" sz="1400" dirty="0"/>
+          </a:p>
+          <a:p>
+            <a:pPr marL="0" indent="0">
+              <a:buNone/>
+            </a:pPr>
+            <a:r>
+              <a:rPr lang="en-US" sz="1400" dirty="0">
+                <a:solidFill>
+                  <a:srgbClr val="FF9D6C"/>
+                </a:solidFill>
+                <a:latin typeface="Consolas" pitchFamily="34" charset="0"/>
+                <a:ea typeface="Consolas" pitchFamily="34" charset="-122"/>
+                <a:cs typeface="Consolas" pitchFamily="34" charset="-120"/>
+              </a:rPr>
+              <a:t>print</a:t>
+            </a:r>
+            <a:r>
+              <a:rPr lang="en-US" sz="1400" dirty="0">
+                <a:solidFill>
+                  <a:srgbClr val="A9D4FF"/>
+                </a:solidFill>
+                <a:latin typeface="Consolas" pitchFamily="34" charset="0"/>
+                <a:ea typeface="Consolas" pitchFamily="34" charset="-122"/>
+                <a:cs typeface="Consolas" pitchFamily="34" charset="-120"/>
+              </a:rPr>
+              <a:t>(s[</a:t>
+            </a:r>
+            <a:r>
+              <a:rPr lang="en-US" sz="1400" dirty="0">
+                <a:solidFill>
+                  <a:srgbClr val="C9A0FF"/>
+                </a:solidFill>
+                <a:latin typeface="Consolas" pitchFamily="34" charset="0"/>
+                <a:ea typeface="Consolas" pitchFamily="34" charset="-122"/>
+                <a:cs typeface="Consolas" pitchFamily="34" charset="-120"/>
+              </a:rPr>
+              <a:t>2</a:t>
+            </a:r>
+            <a:r>
+              <a:rPr lang="en-US" sz="1400" dirty="0">
+                <a:solidFill>
+                  <a:srgbClr val="A9D4FF"/>
+                </a:solidFill>
+                <a:latin typeface="Consolas" pitchFamily="34" charset="0"/>
+                <a:ea typeface="Consolas" pitchFamily="34" charset="-122"/>
+                <a:cs typeface="Consolas" pitchFamily="34" charset="-120"/>
+              </a:rPr>
+              <a:t>])</a:t>
+            </a:r>
+            <a:r>
+              <a:rPr lang="en-US" sz="1400" dirty="0">
+                <a:solidFill>
+                  <a:srgbClr val="7A8BB5"/>
+                </a:solidFill>
+                <a:latin typeface="Consolas" pitchFamily="34" charset="0"/>
+                <a:ea typeface="Consolas" pitchFamily="34" charset="-122"/>
+                <a:cs typeface="Consolas" pitchFamily="34" charset="-120"/>
+              </a:rPr>
+              <a:t>   # "и"</a:t>
+            </a:r>
+            <a:endParaRPr lang="en-US" sz="1400" dirty="0"/>
+          </a:p>
+          <a:p>
+            <a:pPr marL="0" indent="0">
+              <a:buNone/>
+            </a:pPr>
+            <a:r>
+              <a:rPr lang="en-US" sz="1400" dirty="0">
+                <a:solidFill>
+                  <a:srgbClr val="FF9D6C"/>
+                </a:solidFill>
+                <a:latin typeface="Consolas" pitchFamily="34" charset="0"/>
+                <a:ea typeface="Consolas" pitchFamily="34" charset="-122"/>
+                <a:cs typeface="Consolas" pitchFamily="34" charset="-120"/>
+              </a:rPr>
+              <a:t>print</a:t>
+            </a:r>
+            <a:r>
+              <a:rPr lang="en-US" sz="1400" dirty="0">
+                <a:solidFill>
+                  <a:srgbClr val="A9D4FF"/>
+                </a:solidFill>
+                <a:latin typeface="Consolas" pitchFamily="34" charset="0"/>
+                <a:ea typeface="Consolas" pitchFamily="34" charset="-122"/>
+                <a:cs typeface="Consolas" pitchFamily="34" charset="-120"/>
+              </a:rPr>
+              <a:t>(s[</a:t>
+            </a:r>
+            <a:r>
+              <a:rPr lang="en-US" sz="1400" dirty="0">
+                <a:solidFill>
+                  <a:srgbClr val="E84855"/>
+                </a:solidFill>
+                <a:latin typeface="Consolas" pitchFamily="34" charset="0"/>
+                <a:ea typeface="Consolas" pitchFamily="34" charset="-122"/>
+                <a:cs typeface="Consolas" pitchFamily="34" charset="-120"/>
+              </a:rPr>
+              <a:t>-1</a:t>
+            </a:r>
+            <a:r>
+              <a:rPr lang="en-US" sz="1400" dirty="0">
+                <a:solidFill>
+                  <a:srgbClr val="A9D4FF"/>
+                </a:solidFill>
+                <a:latin typeface="Consolas" pitchFamily="34" charset="0"/>
+                <a:ea typeface="Consolas" pitchFamily="34" charset="-122"/>
+                <a:cs typeface="Consolas" pitchFamily="34" charset="-120"/>
+              </a:rPr>
+              <a:t>])</a:t>
+            </a:r>
+            <a:r>
+              <a:rPr lang="en-US" sz="1400" dirty="0">
+                <a:solidFill>
+                  <a:srgbClr val="7A8BB5"/>
+                </a:solidFill>
+                <a:latin typeface="Consolas" pitchFamily="34" charset="0"/>
+                <a:ea typeface="Consolas" pitchFamily="34" charset="-122"/>
+                <a:cs typeface="Consolas" pitchFamily="34" charset="-120"/>
+              </a:rPr>
+              <a:t>  # "т"</a:t>
+            </a:r>
+            <a:endParaRPr lang="en-US" sz="1400" dirty="0"/>
+          </a:p>
+          <a:p>
+            <a:pPr marL="0" indent="0">
+              <a:buNone/>
+            </a:pPr>
+            <a:r>
+              <a:rPr lang="en-US" sz="1400" dirty="0">
+                <a:solidFill>
+                  <a:srgbClr val="FF9D6C"/>
+                </a:solidFill>
+                <a:latin typeface="Consolas" pitchFamily="34" charset="0"/>
+                <a:ea typeface="Consolas" pitchFamily="34" charset="-122"/>
+                <a:cs typeface="Consolas" pitchFamily="34" charset="-120"/>
+              </a:rPr>
+              <a:t>print</a:t>
+            </a:r>
+            <a:r>
+              <a:rPr lang="en-US" sz="1400" dirty="0">
+                <a:solidFill>
+                  <a:srgbClr val="A9D4FF"/>
+                </a:solidFill>
+                <a:latin typeface="Consolas" pitchFamily="34" charset="0"/>
+                <a:ea typeface="Consolas" pitchFamily="34" charset="-122"/>
+                <a:cs typeface="Consolas" pitchFamily="34" charset="-120"/>
+              </a:rPr>
+              <a:t>(s[</a:t>
+            </a:r>
+            <a:r>
+              <a:rPr lang="en-US" sz="1400" dirty="0">
+                <a:solidFill>
+                  <a:srgbClr val="E84855"/>
+                </a:solidFill>
+                <a:latin typeface="Consolas" pitchFamily="34" charset="0"/>
+                <a:ea typeface="Consolas" pitchFamily="34" charset="-122"/>
+                <a:cs typeface="Consolas" pitchFamily="34" charset="-120"/>
+              </a:rPr>
+              <a:t>-2</a:t>
+            </a:r>
+            <a:r>
+              <a:rPr lang="en-US" sz="1400" dirty="0">
+                <a:solidFill>
+                  <a:srgbClr val="A9D4FF"/>
+                </a:solidFill>
+                <a:latin typeface="Consolas" pitchFamily="34" charset="0"/>
+                <a:ea typeface="Consolas" pitchFamily="34" charset="-122"/>
+                <a:cs typeface="Consolas" pitchFamily="34" charset="-120"/>
+              </a:rPr>
+              <a:t>])</a:t>
+            </a:r>
+            <a:r>
+              <a:rPr lang="en-US" sz="1400" dirty="0">
+                <a:solidFill>
+                  <a:srgbClr val="7A8BB5"/>
+                </a:solidFill>
+                <a:latin typeface="Consolas" pitchFamily="34" charset="0"/>
+                <a:ea typeface="Consolas" pitchFamily="34" charset="-122"/>
+                <a:cs typeface="Consolas" pitchFamily="34" charset="-120"/>
+              </a:rPr>
+              <a:t>  # "і"</a:t>
+            </a:r>
+            <a:endParaRPr lang="en-US" sz="1400" dirty="0"/>
+          </a:p>
+        </p:txBody>
+      </p:sp>
+      <p:sp>
+        <p:nvSpPr>
+          <p:cNvPr id="52" name="Shape 50"/>
+          <p:cNvSpPr/>
+          <p:nvPr/>
+        </p:nvSpPr>
+        <p:spPr>
+          <a:xfrm>
+            <a:off x="5257800" y="3401568"/>
+            <a:ext cx="3474720" cy="1600200"/>
+          </a:xfrm>
+          <a:prstGeom prst="rect">
+            <a:avLst/>
+          </a:prstGeom>
+          <a:solidFill>
+            <a:srgbClr val="1A1F36"/>
+          </a:solidFill>
+          <a:ln/>
+          <a:effectLst>
+            <a:outerShdw blurRad="88900" dist="25400" dir="8100000" algn="bl" rotWithShape="0">
+              <a:srgbClr val="000000">
+                <a:alpha val="10000"/>
+              </a:srgbClr>
+            </a:outerShdw>
+          </a:effectLst>
+        </p:spPr>
+        <p:txBody>
+          <a:bodyPr/>
+          <a:lstStyle/>
+          <a:p>
+            <a:endParaRPr lang="en-UA"/>
+          </a:p>
+        </p:txBody>
+      </p:sp>
+      <p:sp>
+        <p:nvSpPr>
+          <p:cNvPr id="53" name="Text 51"/>
+          <p:cNvSpPr/>
+          <p:nvPr/>
+        </p:nvSpPr>
+        <p:spPr>
+          <a:xfrm>
+            <a:off x="5394960" y="3511296"/>
+            <a:ext cx="3200400" cy="347472"/>
+          </a:xfrm>
+          <a:prstGeom prst="rect">
+            <a:avLst/>
+          </a:prstGeom>
+          <a:noFill/>
+          <a:ln/>
+        </p:spPr>
+        <p:txBody>
+          <a:bodyPr wrap="square" lIns="0" tIns="0" rIns="0" bIns="0" rtlCol="0" anchor="ctr"/>
+          <a:lstStyle/>
+          <a:p>
+            <a:pPr marL="0" indent="0">
+              <a:buNone/>
+            </a:pPr>
+            <a:r>
+              <a:rPr lang="en-US" sz="1300" b="1" dirty="0">
+                <a:solidFill>
+                  <a:srgbClr val="5B8FF9"/>
+                </a:solidFill>
+                <a:latin typeface="Calibri" pitchFamily="34" charset="0"/>
+                <a:ea typeface="Calibri" pitchFamily="34" charset="-122"/>
+                <a:cs typeface="Calibri" pitchFamily="34" charset="-120"/>
+              </a:rPr>
+              <a:t>Запам'ятати</a:t>
+            </a:r>
+            <a:endParaRPr lang="en-US" sz="1300" dirty="0"/>
+          </a:p>
+        </p:txBody>
+      </p:sp>
+      <p:sp>
+        <p:nvSpPr>
+          <p:cNvPr id="54" name="Shape 52"/>
+          <p:cNvSpPr/>
+          <p:nvPr/>
+        </p:nvSpPr>
+        <p:spPr>
+          <a:xfrm>
+            <a:off x="5394960" y="3950208"/>
+            <a:ext cx="54864" cy="292608"/>
+          </a:xfrm>
+          <a:prstGeom prst="rect">
+            <a:avLst/>
+          </a:prstGeom>
+          <a:solidFill>
+            <a:srgbClr val="3DC9B0"/>
+          </a:solidFill>
+          <a:ln w="12700">
+            <a:solidFill>
+              <a:srgbClr val="3DC9B0"/>
+            </a:solidFill>
+            <a:prstDash val="solid"/>
+          </a:ln>
+        </p:spPr>
+        <p:txBody>
+          <a:bodyPr/>
+          <a:lstStyle/>
+          <a:p>
+            <a:endParaRPr lang="en-UA"/>
+          </a:p>
+        </p:txBody>
+      </p:sp>
+      <p:sp>
+        <p:nvSpPr>
+          <p:cNvPr id="55" name="Text 53"/>
+          <p:cNvSpPr/>
+          <p:nvPr/>
+        </p:nvSpPr>
+        <p:spPr>
+          <a:xfrm>
+            <a:off x="5559552" y="3950208"/>
+            <a:ext cx="3017520" cy="292608"/>
+          </a:xfrm>
+          <a:prstGeom prst="rect">
+            <a:avLst/>
+          </a:prstGeom>
+          <a:noFill/>
+          <a:ln/>
+        </p:spPr>
+        <p:txBody>
+          <a:bodyPr wrap="square" lIns="0" tIns="0" rIns="0" bIns="0" rtlCol="0" anchor="ctr"/>
+          <a:lstStyle/>
+          <a:p>
+            <a:pPr marL="0" indent="0">
+              <a:buNone/>
+            </a:pPr>
+            <a:r>
+              <a:rPr lang="en-US" sz="1200" dirty="0">
+                <a:solidFill>
+                  <a:srgbClr val="7A8BB5"/>
+                </a:solidFill>
+                <a:latin typeface="Calibri" pitchFamily="34" charset="0"/>
+                <a:ea typeface="Calibri" pitchFamily="34" charset="-122"/>
+                <a:cs typeface="Calibri" pitchFamily="34" charset="-120"/>
+              </a:rPr>
+              <a:t>Перший символ — індекс 0</a:t>
+            </a:r>
+            <a:endParaRPr lang="en-US" sz="1200" dirty="0"/>
+          </a:p>
+        </p:txBody>
+      </p:sp>
+      <p:sp>
+        <p:nvSpPr>
+          <p:cNvPr id="56" name="Shape 54"/>
+          <p:cNvSpPr/>
+          <p:nvPr/>
+        </p:nvSpPr>
+        <p:spPr>
+          <a:xfrm>
+            <a:off x="5394960" y="4297680"/>
+            <a:ext cx="54864" cy="292608"/>
+          </a:xfrm>
+          <a:prstGeom prst="rect">
+            <a:avLst/>
+          </a:prstGeom>
+          <a:solidFill>
+            <a:srgbClr val="3DC9B0"/>
+          </a:solidFill>
+          <a:ln w="12700">
+            <a:solidFill>
+              <a:srgbClr val="3DC9B0"/>
+            </a:solidFill>
+            <a:prstDash val="solid"/>
+          </a:ln>
+        </p:spPr>
+        <p:txBody>
+          <a:bodyPr/>
+          <a:lstStyle/>
+          <a:p>
+            <a:endParaRPr lang="en-UA"/>
+          </a:p>
+        </p:txBody>
+      </p:sp>
+      <p:sp>
+        <p:nvSpPr>
+          <p:cNvPr id="57" name="Text 55"/>
+          <p:cNvSpPr/>
+          <p:nvPr/>
+        </p:nvSpPr>
+        <p:spPr>
+          <a:xfrm>
+            <a:off x="5559552" y="4297680"/>
+            <a:ext cx="3017520" cy="292608"/>
+          </a:xfrm>
+          <a:prstGeom prst="rect">
+            <a:avLst/>
+          </a:prstGeom>
+          <a:noFill/>
+          <a:ln/>
+        </p:spPr>
+        <p:txBody>
+          <a:bodyPr wrap="square" lIns="0" tIns="0" rIns="0" bIns="0" rtlCol="0" anchor="ctr"/>
+          <a:lstStyle/>
+          <a:p>
+            <a:pPr marL="0" indent="0">
+              <a:buNone/>
+            </a:pPr>
+            <a:r>
+              <a:rPr lang="en-US" sz="1200" dirty="0">
+                <a:solidFill>
+                  <a:srgbClr val="7A8BB5"/>
+                </a:solidFill>
+                <a:latin typeface="Calibri" pitchFamily="34" charset="0"/>
+                <a:ea typeface="Calibri" pitchFamily="34" charset="-122"/>
+                <a:cs typeface="Calibri" pitchFamily="34" charset="-120"/>
+              </a:rPr>
+              <a:t>-1 — завжди останній символ</a:t>
+            </a:r>
+            <a:endParaRPr lang="en-US" sz="1200" dirty="0"/>
+          </a:p>
+        </p:txBody>
+      </p:sp>
+      <p:sp>
+        <p:nvSpPr>
+          <p:cNvPr id="58" name="Shape 56"/>
+          <p:cNvSpPr/>
+          <p:nvPr/>
+        </p:nvSpPr>
+        <p:spPr>
+          <a:xfrm>
+            <a:off x="5394960" y="4645152"/>
+            <a:ext cx="54864" cy="292608"/>
+          </a:xfrm>
+          <a:prstGeom prst="rect">
+            <a:avLst/>
+          </a:prstGeom>
+          <a:solidFill>
+            <a:srgbClr val="3DC9B0"/>
+          </a:solidFill>
+          <a:ln w="12700">
+            <a:solidFill>
+              <a:srgbClr val="3DC9B0"/>
+            </a:solidFill>
+            <a:prstDash val="solid"/>
+          </a:ln>
+        </p:spPr>
+        <p:txBody>
+          <a:bodyPr/>
+          <a:lstStyle/>
+          <a:p>
+            <a:endParaRPr lang="en-UA"/>
+          </a:p>
+        </p:txBody>
+      </p:sp>
+      <p:sp>
+        <p:nvSpPr>
+          <p:cNvPr id="59" name="Text 57"/>
+          <p:cNvSpPr/>
+          <p:nvPr/>
+        </p:nvSpPr>
+        <p:spPr>
+          <a:xfrm>
+            <a:off x="5559552" y="4645152"/>
+            <a:ext cx="3017520" cy="292608"/>
+          </a:xfrm>
+          <a:prstGeom prst="rect">
+            <a:avLst/>
+          </a:prstGeom>
+          <a:noFill/>
+          <a:ln/>
+        </p:spPr>
+        <p:txBody>
+          <a:bodyPr wrap="square" lIns="0" tIns="0" rIns="0" bIns="0" rtlCol="0" anchor="ctr"/>
+          <a:lstStyle/>
+          <a:p>
+            <a:pPr marL="0" indent="0">
+              <a:buNone/>
+            </a:pPr>
+            <a:r>
+              <a:rPr lang="en-US" sz="1200" dirty="0">
+                <a:solidFill>
+                  <a:srgbClr val="7A8BB5"/>
+                </a:solidFill>
+                <a:latin typeface="Calibri" pitchFamily="34" charset="0"/>
+                <a:ea typeface="Calibri" pitchFamily="34" charset="-122"/>
+                <a:cs typeface="Calibri" pitchFamily="34" charset="-120"/>
+              </a:rPr>
+              <a:t>Виходити за межі → помилка</a:t>
+            </a:r>
+            <a:endParaRPr lang="en-US" sz="1200" dirty="0"/>
+          </a:p>
+        </p:txBody>
+      </p:sp>
+    </p:spTree>
+  </p:cSld>
+  <p:clrMapOvr>
+    <a:masterClrMapping/>
+  </p:clrMapOvr>
+</p:sld>
+</file>
+
+<file path=ppt/slides/slide16.xml><?xml version="1.0" encoding="utf-8"?>
+<p:sld xmlns:a="http://schemas.openxmlformats.org/drawingml/2006/main" xmlns:r="http://schemas.openxmlformats.org/officeDocument/2006/relationships" xmlns:p="http://schemas.openxmlformats.org/presentationml/2006/main">
+  <p:cSld>
+    <p:spTree>
+      <p:nvGrpSpPr>
+        <p:cNvPr id="1" name=""/>
+        <p:cNvGrpSpPr/>
+        <p:nvPr/>
+      </p:nvGrpSpPr>
+      <p:grpSpPr>
+        <a:xfrm>
+          <a:off x="0" y="0"/>
+          <a:ext cx="0" cy="0"/>
+          <a:chOff x="0" y="0"/>
+          <a:chExt cx="0" cy="0"/>
+        </a:xfrm>
+      </p:grpSpPr>
+      <p:sp>
+        <p:nvSpPr>
+          <p:cNvPr id="2" name="Text 0"/>
+          <p:cNvSpPr/>
+          <p:nvPr/>
+        </p:nvSpPr>
+        <p:spPr>
+          <a:xfrm>
+            <a:off x="457200" y="182880"/>
+            <a:ext cx="8229600" cy="658368"/>
+          </a:xfrm>
+          <a:prstGeom prst="rect">
+            <a:avLst/>
+          </a:prstGeom>
+          <a:noFill/>
+          <a:ln/>
+        </p:spPr>
+        <p:txBody>
+          <a:bodyPr wrap="square" lIns="0" tIns="0" rIns="0" bIns="0" rtlCol="0" anchor="ctr"/>
+          <a:lstStyle/>
+          <a:p>
+            <a:pPr marL="0" indent="0">
+              <a:buNone/>
+            </a:pPr>
+            <a:r>
+              <a:rPr lang="en-US" sz="3000" b="1" dirty="0">
+                <a:solidFill>
+                  <a:srgbClr val="1A1F36"/>
+                </a:solidFill>
+                <a:latin typeface="Trebuchet MS" pitchFamily="34" charset="0"/>
+                <a:ea typeface="Trebuchet MS" pitchFamily="34" charset="-122"/>
+                <a:cs typeface="Trebuchet MS" pitchFamily="34" charset="-120"/>
+              </a:rPr>
+              <a:t>Зрізи рядків (slicing)</a:t>
+            </a:r>
+            <a:endParaRPr lang="en-US" sz="3000" dirty="0"/>
+          </a:p>
+        </p:txBody>
+      </p:sp>
+      <p:sp>
+        <p:nvSpPr>
+          <p:cNvPr id="3" name="Shape 1"/>
+          <p:cNvSpPr/>
+          <p:nvPr/>
+        </p:nvSpPr>
+        <p:spPr>
+          <a:xfrm>
+            <a:off x="7589520" y="164592"/>
+            <a:ext cx="1371600" cy="347472"/>
+          </a:xfrm>
+          <a:prstGeom prst="roundRect">
+            <a:avLst>
+              <a:gd name="adj" fmla="val 18421"/>
+            </a:avLst>
+          </a:prstGeom>
+          <a:solidFill>
+            <a:srgbClr val="5B8FF9"/>
+          </a:solidFill>
+          <a:ln w="12700">
+            <a:solidFill>
+              <a:srgbClr val="5B8FF9"/>
+            </a:solidFill>
+            <a:prstDash val="solid"/>
+          </a:ln>
+        </p:spPr>
+        <p:txBody>
+          <a:bodyPr/>
+          <a:lstStyle/>
+          <a:p>
+            <a:endParaRPr lang="en-UA"/>
+          </a:p>
+        </p:txBody>
+      </p:sp>
+      <p:sp>
+        <p:nvSpPr>
+          <p:cNvPr id="4" name="Text 2"/>
+          <p:cNvSpPr/>
+          <p:nvPr/>
+        </p:nvSpPr>
+        <p:spPr>
+          <a:xfrm>
+            <a:off x="7589520" y="164592"/>
+            <a:ext cx="1371600" cy="347472"/>
+          </a:xfrm>
+          <a:prstGeom prst="rect">
+            <a:avLst/>
+          </a:prstGeom>
+          <a:noFill/>
+          <a:ln/>
+        </p:spPr>
+        <p:txBody>
+          <a:bodyPr wrap="square" lIns="0" tIns="0" rIns="0" bIns="0" rtlCol="0" anchor="ctr"/>
+          <a:lstStyle/>
+          <a:p>
+            <a:pPr marL="0" indent="0" algn="ctr">
+              <a:buNone/>
+            </a:pPr>
+            <a:r>
+              <a:rPr lang="en-US" sz="1100" b="1" dirty="0">
+                <a:solidFill>
+                  <a:srgbClr val="FFFFFF"/>
+                </a:solidFill>
+                <a:latin typeface="Calibri" pitchFamily="34" charset="0"/>
+                <a:ea typeface="Calibri" pitchFamily="34" charset="-122"/>
+                <a:cs typeface="Calibri" pitchFamily="34" charset="-120"/>
+              </a:rPr>
+              <a:t>Теорія</a:t>
+            </a:r>
+            <a:endParaRPr lang="en-US" sz="1100" dirty="0"/>
+          </a:p>
+        </p:txBody>
+      </p:sp>
+      <p:sp>
+        <p:nvSpPr>
+          <p:cNvPr id="5" name="Text 3"/>
+          <p:cNvSpPr/>
+          <p:nvPr/>
+        </p:nvSpPr>
+        <p:spPr>
+          <a:xfrm>
+            <a:off x="457200" y="960120"/>
+            <a:ext cx="8229600" cy="384048"/>
+          </a:xfrm>
+          <a:prstGeom prst="rect">
+            <a:avLst/>
+          </a:prstGeom>
+          <a:noFill/>
+          <a:ln/>
+        </p:spPr>
+        <p:txBody>
+          <a:bodyPr wrap="square" lIns="0" tIns="0" rIns="0" bIns="0" rtlCol="0" anchor="ctr"/>
+          <a:lstStyle/>
+          <a:p>
+            <a:pPr marL="0" indent="0">
+              <a:buNone/>
+            </a:pPr>
+            <a:r>
+              <a:rPr lang="en-US" sz="1500" i="1" dirty="0">
+                <a:solidFill>
+                  <a:srgbClr val="7A8BB5"/>
+                </a:solidFill>
+                <a:latin typeface="Calibri" pitchFamily="34" charset="0"/>
+                <a:ea typeface="Calibri" pitchFamily="34" charset="-122"/>
+                <a:cs typeface="Calibri" pitchFamily="34" charset="-120"/>
+              </a:rPr>
+              <a:t>Зріз дозволяє отримати частину рядка: s[початок : кінець : крок]</a:t>
+            </a:r>
+            <a:endParaRPr lang="en-US" sz="1500" dirty="0"/>
+          </a:p>
+        </p:txBody>
+      </p:sp>
+      <p:sp>
+        <p:nvSpPr>
+          <p:cNvPr id="6" name="Shape 4"/>
+          <p:cNvSpPr/>
+          <p:nvPr/>
+        </p:nvSpPr>
+        <p:spPr>
+          <a:xfrm>
+            <a:off x="457200" y="1417320"/>
+            <a:ext cx="8229600" cy="594360"/>
+          </a:xfrm>
+          <a:prstGeom prst="rect">
+            <a:avLst/>
+          </a:prstGeom>
+          <a:solidFill>
+            <a:srgbClr val="1A1F36"/>
+          </a:solidFill>
+          <a:ln w="12700">
+            <a:solidFill>
+              <a:srgbClr val="2A3358"/>
+            </a:solidFill>
+            <a:prstDash val="solid"/>
+          </a:ln>
+        </p:spPr>
+        <p:txBody>
+          <a:bodyPr/>
+          <a:lstStyle/>
+          <a:p>
+            <a:endParaRPr lang="en-UA"/>
+          </a:p>
+        </p:txBody>
+      </p:sp>
+      <p:sp>
+        <p:nvSpPr>
+          <p:cNvPr id="7" name="Text 5"/>
+          <p:cNvSpPr/>
+          <p:nvPr/>
+        </p:nvSpPr>
+        <p:spPr>
+          <a:xfrm>
+            <a:off x="640080" y="1417320"/>
+            <a:ext cx="7863840" cy="594360"/>
+          </a:xfrm>
+          <a:prstGeom prst="rect">
+            <a:avLst/>
+          </a:prstGeom>
+          <a:noFill/>
+          <a:ln/>
+        </p:spPr>
+        <p:txBody>
+          <a:bodyPr wrap="square" lIns="0" tIns="0" rIns="0" bIns="0" rtlCol="0" anchor="ctr"/>
+          <a:lstStyle/>
+          <a:p>
+            <a:pPr marL="0" indent="0">
+              <a:buNone/>
+            </a:pPr>
+            <a:r>
+              <a:rPr lang="en-US" sz="1700" dirty="0">
+                <a:solidFill>
+                  <a:srgbClr val="A9D4FF"/>
+                </a:solidFill>
+                <a:latin typeface="Consolas" pitchFamily="34" charset="0"/>
+                <a:ea typeface="Consolas" pitchFamily="34" charset="-122"/>
+                <a:cs typeface="Consolas" pitchFamily="34" charset="-120"/>
+              </a:rPr>
+              <a:t>s[</a:t>
+            </a:r>
+            <a:r>
+              <a:rPr lang="en-US" sz="1700" dirty="0">
+                <a:solidFill>
+                  <a:srgbClr val="5B8FF9"/>
+                </a:solidFill>
+                <a:latin typeface="Consolas" pitchFamily="34" charset="0"/>
+                <a:ea typeface="Consolas" pitchFamily="34" charset="-122"/>
+                <a:cs typeface="Consolas" pitchFamily="34" charset="-120"/>
+              </a:rPr>
+              <a:t>початок</a:t>
+            </a:r>
+            <a:r>
+              <a:rPr lang="en-US" sz="1700" dirty="0">
+                <a:solidFill>
+                  <a:srgbClr val="A9D4FF"/>
+                </a:solidFill>
+                <a:latin typeface="Consolas" pitchFamily="34" charset="0"/>
+                <a:ea typeface="Consolas" pitchFamily="34" charset="-122"/>
+                <a:cs typeface="Consolas" pitchFamily="34" charset="-120"/>
+              </a:rPr>
+              <a:t> : </a:t>
+            </a:r>
+            <a:r>
+              <a:rPr lang="en-US" sz="1700" dirty="0">
+                <a:solidFill>
+                  <a:srgbClr val="FF9D6C"/>
+                </a:solidFill>
+                <a:latin typeface="Consolas" pitchFamily="34" charset="0"/>
+                <a:ea typeface="Consolas" pitchFamily="34" charset="-122"/>
+                <a:cs typeface="Consolas" pitchFamily="34" charset="-120"/>
+              </a:rPr>
+              <a:t>кінець</a:t>
+            </a:r>
+            <a:r>
+              <a:rPr lang="en-US" sz="1700" dirty="0">
+                <a:solidFill>
+                  <a:srgbClr val="A9D4FF"/>
+                </a:solidFill>
+                <a:latin typeface="Consolas" pitchFamily="34" charset="0"/>
+                <a:ea typeface="Consolas" pitchFamily="34" charset="-122"/>
+                <a:cs typeface="Consolas" pitchFamily="34" charset="-120"/>
+              </a:rPr>
+              <a:t> : </a:t>
+            </a:r>
+            <a:r>
+              <a:rPr lang="en-US" sz="1700" dirty="0">
+                <a:solidFill>
+                  <a:srgbClr val="3DC9B0"/>
+                </a:solidFill>
+                <a:latin typeface="Consolas" pitchFamily="34" charset="0"/>
+                <a:ea typeface="Consolas" pitchFamily="34" charset="-122"/>
+                <a:cs typeface="Consolas" pitchFamily="34" charset="-120"/>
+              </a:rPr>
+              <a:t>крок</a:t>
+            </a:r>
+            <a:r>
+              <a:rPr lang="en-US" sz="1700" dirty="0">
+                <a:solidFill>
+                  <a:srgbClr val="A9D4FF"/>
+                </a:solidFill>
+                <a:latin typeface="Consolas" pitchFamily="34" charset="0"/>
+                <a:ea typeface="Consolas" pitchFamily="34" charset="-122"/>
+                <a:cs typeface="Consolas" pitchFamily="34" charset="-120"/>
+              </a:rPr>
+              <a:t>]</a:t>
+            </a:r>
+            <a:r>
+              <a:rPr lang="en-US" sz="1700" dirty="0">
+                <a:solidFill>
+                  <a:srgbClr val="7A8BB5"/>
+                </a:solidFill>
+                <a:latin typeface="Consolas" pitchFamily="34" charset="0"/>
+                <a:ea typeface="Consolas" pitchFamily="34" charset="-122"/>
+                <a:cs typeface="Consolas" pitchFamily="34" charset="-120"/>
+              </a:rPr>
+              <a:t>   ← кінець не включається!</a:t>
+            </a:r>
+            <a:endParaRPr lang="en-US" sz="1700" dirty="0"/>
+          </a:p>
+        </p:txBody>
+      </p:sp>
+      <p:sp>
+        <p:nvSpPr>
+          <p:cNvPr id="8" name="Shape 6"/>
+          <p:cNvSpPr/>
+          <p:nvPr/>
+        </p:nvSpPr>
+        <p:spPr>
+          <a:xfrm>
+            <a:off x="457200" y="2103120"/>
+            <a:ext cx="4754880" cy="2560320"/>
+          </a:xfrm>
+          <a:prstGeom prst="rect">
+            <a:avLst/>
+          </a:prstGeom>
+          <a:solidFill>
+            <a:srgbClr val="161B2E"/>
+          </a:solidFill>
+          <a:ln w="12700">
+            <a:solidFill>
+              <a:srgbClr val="2A3358"/>
+            </a:solidFill>
+            <a:prstDash val="solid"/>
+          </a:ln>
+        </p:spPr>
+        <p:txBody>
+          <a:bodyPr/>
+          <a:lstStyle/>
+          <a:p>
+            <a:endParaRPr lang="en-UA"/>
+          </a:p>
+        </p:txBody>
+      </p:sp>
+      <p:sp>
+        <p:nvSpPr>
+          <p:cNvPr id="9" name="Shape 7"/>
+          <p:cNvSpPr/>
+          <p:nvPr/>
+        </p:nvSpPr>
+        <p:spPr>
+          <a:xfrm>
+            <a:off x="621792" y="2221992"/>
+            <a:ext cx="109728" cy="109728"/>
+          </a:xfrm>
+          <a:prstGeom prst="ellipse">
+            <a:avLst/>
+          </a:prstGeom>
+          <a:solidFill>
+            <a:srgbClr val="FF5F57"/>
+          </a:solidFill>
+          <a:ln w="12700">
+            <a:solidFill>
+              <a:srgbClr val="FF5F57"/>
+            </a:solidFill>
+            <a:prstDash val="solid"/>
+          </a:ln>
+        </p:spPr>
+        <p:txBody>
+          <a:bodyPr/>
+          <a:lstStyle/>
+          <a:p>
+            <a:endParaRPr lang="en-UA"/>
+          </a:p>
+        </p:txBody>
+      </p:sp>
+      <p:sp>
+        <p:nvSpPr>
+          <p:cNvPr id="10" name="Shape 8"/>
+          <p:cNvSpPr/>
+          <p:nvPr/>
+        </p:nvSpPr>
+        <p:spPr>
+          <a:xfrm>
+            <a:off x="822960" y="2221992"/>
+            <a:ext cx="109728" cy="109728"/>
+          </a:xfrm>
+          <a:prstGeom prst="ellipse">
+            <a:avLst/>
+          </a:prstGeom>
+          <a:solidFill>
+            <a:srgbClr val="FEBC2E"/>
+          </a:solidFill>
+          <a:ln w="12700">
+            <a:solidFill>
+              <a:srgbClr val="FEBC2E"/>
+            </a:solidFill>
+            <a:prstDash val="solid"/>
+          </a:ln>
+        </p:spPr>
+        <p:txBody>
+          <a:bodyPr/>
+          <a:lstStyle/>
+          <a:p>
+            <a:endParaRPr lang="en-UA"/>
+          </a:p>
+        </p:txBody>
+      </p:sp>
+      <p:sp>
+        <p:nvSpPr>
+          <p:cNvPr id="11" name="Shape 9"/>
+          <p:cNvSpPr/>
+          <p:nvPr/>
+        </p:nvSpPr>
+        <p:spPr>
+          <a:xfrm>
+            <a:off x="1024128" y="2221992"/>
+            <a:ext cx="109728" cy="109728"/>
+          </a:xfrm>
+          <a:prstGeom prst="ellipse">
+            <a:avLst/>
+          </a:prstGeom>
+          <a:solidFill>
+            <a:srgbClr val="28C840"/>
+          </a:solidFill>
+          <a:ln w="12700">
+            <a:solidFill>
+              <a:srgbClr val="28C840"/>
+            </a:solidFill>
+            <a:prstDash val="solid"/>
+          </a:ln>
+        </p:spPr>
+        <p:txBody>
+          <a:bodyPr/>
+          <a:lstStyle/>
+          <a:p>
+            <a:endParaRPr lang="en-UA"/>
+          </a:p>
+        </p:txBody>
+      </p:sp>
+      <p:sp>
+        <p:nvSpPr>
+          <p:cNvPr id="12" name="Text 10"/>
+          <p:cNvSpPr/>
+          <p:nvPr/>
+        </p:nvSpPr>
+        <p:spPr>
+          <a:xfrm>
+            <a:off x="594360" y="2423160"/>
+            <a:ext cx="4480560" cy="2148840"/>
+          </a:xfrm>
+          <a:prstGeom prst="rect">
+            <a:avLst/>
+          </a:prstGeom>
+          <a:noFill/>
+          <a:ln/>
+        </p:spPr>
+        <p:txBody>
+          <a:bodyPr wrap="square" lIns="0" tIns="0" rIns="0" bIns="0" rtlCol="0" anchor="t"/>
+          <a:lstStyle/>
+          <a:p>
+            <a:pPr marL="0" indent="0">
+              <a:buNone/>
+            </a:pPr>
+            <a:r>
+              <a:rPr lang="en-US" sz="1400" dirty="0">
+                <a:solidFill>
+                  <a:srgbClr val="A9D4FF"/>
+                </a:solidFill>
+                <a:latin typeface="Consolas" pitchFamily="34" charset="0"/>
+                <a:ea typeface="Consolas" pitchFamily="34" charset="-122"/>
+                <a:cs typeface="Consolas" pitchFamily="34" charset="-120"/>
+              </a:rPr>
+              <a:t>s</a:t>
+            </a:r>
+            <a:r>
+              <a:rPr lang="en-US" sz="1400" dirty="0">
+                <a:solidFill>
+                  <a:srgbClr val="7A8BB5"/>
+                </a:solidFill>
+                <a:latin typeface="Consolas" pitchFamily="34" charset="0"/>
+                <a:ea typeface="Consolas" pitchFamily="34" charset="-122"/>
+                <a:cs typeface="Consolas" pitchFamily="34" charset="-120"/>
+              </a:rPr>
+              <a:t> = </a:t>
+            </a:r>
+            <a:r>
+              <a:rPr lang="en-US" sz="1400" dirty="0">
+                <a:solidFill>
+                  <a:srgbClr val="6DDC8B"/>
+                </a:solidFill>
+                <a:latin typeface="Consolas" pitchFamily="34" charset="0"/>
+                <a:ea typeface="Consolas" pitchFamily="34" charset="-122"/>
+                <a:cs typeface="Consolas" pitchFamily="34" charset="-120"/>
+              </a:rPr>
+              <a:t>"Привіт"</a:t>
+            </a:r>
+            <a:endParaRPr lang="en-US" sz="1400" dirty="0"/>
+          </a:p>
+          <a:p>
+            <a:pPr marL="0" indent="0">
+              <a:buNone/>
+            </a:pPr>
+            <a:endParaRPr lang="en-US" sz="1400" dirty="0"/>
+          </a:p>
+          <a:p>
+            <a:pPr marL="0" indent="0">
+              <a:buNone/>
+            </a:pPr>
+            <a:r>
+              <a:rPr lang="en-US" sz="1400" dirty="0">
+                <a:solidFill>
+                  <a:srgbClr val="FF9D6C"/>
+                </a:solidFill>
+                <a:latin typeface="Consolas" pitchFamily="34" charset="0"/>
+                <a:ea typeface="Consolas" pitchFamily="34" charset="-122"/>
+                <a:cs typeface="Consolas" pitchFamily="34" charset="-120"/>
+              </a:rPr>
+              <a:t>print</a:t>
+            </a:r>
+            <a:r>
+              <a:rPr lang="en-US" sz="1400" dirty="0">
+                <a:solidFill>
+                  <a:srgbClr val="A9D4FF"/>
+                </a:solidFill>
+                <a:latin typeface="Consolas" pitchFamily="34" charset="0"/>
+                <a:ea typeface="Consolas" pitchFamily="34" charset="-122"/>
+                <a:cs typeface="Consolas" pitchFamily="34" charset="-120"/>
+              </a:rPr>
+              <a:t>(s[</a:t>
+            </a:r>
+            <a:r>
+              <a:rPr lang="en-US" sz="1400" dirty="0">
+                <a:solidFill>
+                  <a:srgbClr val="5B8FF9"/>
+                </a:solidFill>
+                <a:latin typeface="Consolas" pitchFamily="34" charset="0"/>
+                <a:ea typeface="Consolas" pitchFamily="34" charset="-122"/>
+                <a:cs typeface="Consolas" pitchFamily="34" charset="-120"/>
+              </a:rPr>
+              <a:t>0</a:t>
+            </a:r>
+            <a:r>
+              <a:rPr lang="en-US" sz="1400" dirty="0">
+                <a:solidFill>
+                  <a:srgbClr val="A9D4FF"/>
+                </a:solidFill>
+                <a:latin typeface="Consolas" pitchFamily="34" charset="0"/>
+                <a:ea typeface="Consolas" pitchFamily="34" charset="-122"/>
+                <a:cs typeface="Consolas" pitchFamily="34" charset="-120"/>
+              </a:rPr>
+              <a:t>:</a:t>
+            </a:r>
+            <a:r>
+              <a:rPr lang="en-US" sz="1400" dirty="0">
+                <a:solidFill>
+                  <a:srgbClr val="FF9D6C"/>
+                </a:solidFill>
+                <a:latin typeface="Consolas" pitchFamily="34" charset="0"/>
+                <a:ea typeface="Consolas" pitchFamily="34" charset="-122"/>
+                <a:cs typeface="Consolas" pitchFamily="34" charset="-120"/>
+              </a:rPr>
+              <a:t>3</a:t>
+            </a:r>
+            <a:r>
+              <a:rPr lang="en-US" sz="1400" dirty="0">
+                <a:solidFill>
+                  <a:srgbClr val="A9D4FF"/>
+                </a:solidFill>
+                <a:latin typeface="Consolas" pitchFamily="34" charset="0"/>
+                <a:ea typeface="Consolas" pitchFamily="34" charset="-122"/>
+                <a:cs typeface="Consolas" pitchFamily="34" charset="-120"/>
+              </a:rPr>
+              <a:t>])</a:t>
+            </a:r>
+            <a:r>
+              <a:rPr lang="en-US" sz="1400" dirty="0">
+                <a:solidFill>
+                  <a:srgbClr val="7A8BB5"/>
+                </a:solidFill>
+                <a:latin typeface="Consolas" pitchFamily="34" charset="0"/>
+                <a:ea typeface="Consolas" pitchFamily="34" charset="-122"/>
+                <a:cs typeface="Consolas" pitchFamily="34" charset="-120"/>
+              </a:rPr>
+              <a:t>    # "При"</a:t>
+            </a:r>
+            <a:endParaRPr lang="en-US" sz="1400" dirty="0"/>
+          </a:p>
+          <a:p>
+            <a:pPr marL="0" indent="0">
+              <a:buNone/>
+            </a:pPr>
+            <a:r>
+              <a:rPr lang="en-US" sz="1400" dirty="0">
+                <a:solidFill>
+                  <a:srgbClr val="FF9D6C"/>
+                </a:solidFill>
+                <a:latin typeface="Consolas" pitchFamily="34" charset="0"/>
+                <a:ea typeface="Consolas" pitchFamily="34" charset="-122"/>
+                <a:cs typeface="Consolas" pitchFamily="34" charset="-120"/>
+              </a:rPr>
+              <a:t>print</a:t>
+            </a:r>
+            <a:r>
+              <a:rPr lang="en-US" sz="1400" dirty="0">
+                <a:solidFill>
+                  <a:srgbClr val="A9D4FF"/>
+                </a:solidFill>
+                <a:latin typeface="Consolas" pitchFamily="34" charset="0"/>
+                <a:ea typeface="Consolas" pitchFamily="34" charset="-122"/>
+                <a:cs typeface="Consolas" pitchFamily="34" charset="-120"/>
+              </a:rPr>
+              <a:t>(s[</a:t>
+            </a:r>
+            <a:r>
+              <a:rPr lang="en-US" sz="1400" dirty="0">
+                <a:solidFill>
+                  <a:srgbClr val="5B8FF9"/>
+                </a:solidFill>
+                <a:latin typeface="Consolas" pitchFamily="34" charset="0"/>
+                <a:ea typeface="Consolas" pitchFamily="34" charset="-122"/>
+                <a:cs typeface="Consolas" pitchFamily="34" charset="-120"/>
+              </a:rPr>
+              <a:t>3</a:t>
+            </a:r>
+            <a:r>
+              <a:rPr lang="en-US" sz="1400" dirty="0">
+                <a:solidFill>
+                  <a:srgbClr val="A9D4FF"/>
+                </a:solidFill>
+                <a:latin typeface="Consolas" pitchFamily="34" charset="0"/>
+                <a:ea typeface="Consolas" pitchFamily="34" charset="-122"/>
+                <a:cs typeface="Consolas" pitchFamily="34" charset="-120"/>
+              </a:rPr>
+              <a:t>:])</a:t>
+            </a:r>
+            <a:r>
+              <a:rPr lang="en-US" sz="1400" dirty="0">
+                <a:solidFill>
+                  <a:srgbClr val="7A8BB5"/>
+                </a:solidFill>
+                <a:latin typeface="Consolas" pitchFamily="34" charset="0"/>
+                <a:ea typeface="Consolas" pitchFamily="34" charset="-122"/>
+                <a:cs typeface="Consolas" pitchFamily="34" charset="-120"/>
+              </a:rPr>
+              <a:t>     # "віт"</a:t>
+            </a:r>
+            <a:endParaRPr lang="en-US" sz="1400" dirty="0"/>
+          </a:p>
+          <a:p>
+            <a:pPr marL="0" indent="0">
+              <a:buNone/>
+            </a:pPr>
+            <a:r>
+              <a:rPr lang="en-US" sz="1400" dirty="0">
+                <a:solidFill>
+                  <a:srgbClr val="FF9D6C"/>
+                </a:solidFill>
+                <a:latin typeface="Consolas" pitchFamily="34" charset="0"/>
+                <a:ea typeface="Consolas" pitchFamily="34" charset="-122"/>
+                <a:cs typeface="Consolas" pitchFamily="34" charset="-120"/>
+              </a:rPr>
+              <a:t>print</a:t>
+            </a:r>
+            <a:r>
+              <a:rPr lang="en-US" sz="1400" dirty="0">
+                <a:solidFill>
+                  <a:srgbClr val="A9D4FF"/>
+                </a:solidFill>
+                <a:latin typeface="Consolas" pitchFamily="34" charset="0"/>
+                <a:ea typeface="Consolas" pitchFamily="34" charset="-122"/>
+                <a:cs typeface="Consolas" pitchFamily="34" charset="-120"/>
+              </a:rPr>
+              <a:t>(s[:</a:t>
+            </a:r>
+            <a:r>
+              <a:rPr lang="en-US" sz="1400" dirty="0">
+                <a:solidFill>
+                  <a:srgbClr val="FF9D6C"/>
+                </a:solidFill>
+                <a:latin typeface="Consolas" pitchFamily="34" charset="0"/>
+                <a:ea typeface="Consolas" pitchFamily="34" charset="-122"/>
+                <a:cs typeface="Consolas" pitchFamily="34" charset="-120"/>
+              </a:rPr>
+              <a:t>3</a:t>
+            </a:r>
+            <a:r>
+              <a:rPr lang="en-US" sz="1400" dirty="0">
+                <a:solidFill>
+                  <a:srgbClr val="A9D4FF"/>
+                </a:solidFill>
+                <a:latin typeface="Consolas" pitchFamily="34" charset="0"/>
+                <a:ea typeface="Consolas" pitchFamily="34" charset="-122"/>
+                <a:cs typeface="Consolas" pitchFamily="34" charset="-120"/>
+              </a:rPr>
+              <a:t>])</a:t>
+            </a:r>
+            <a:r>
+              <a:rPr lang="en-US" sz="1400" dirty="0">
+                <a:solidFill>
+                  <a:srgbClr val="7A8BB5"/>
+                </a:solidFill>
+                <a:latin typeface="Consolas" pitchFamily="34" charset="0"/>
+                <a:ea typeface="Consolas" pitchFamily="34" charset="-122"/>
+                <a:cs typeface="Consolas" pitchFamily="34" charset="-120"/>
+              </a:rPr>
+              <a:t>     # "При"</a:t>
+            </a:r>
+            <a:endParaRPr lang="en-US" sz="1400" dirty="0"/>
+          </a:p>
+          <a:p>
+            <a:pPr marL="0" indent="0">
+              <a:buNone/>
+            </a:pPr>
+            <a:r>
+              <a:rPr lang="en-US" sz="1400" dirty="0">
+                <a:solidFill>
+                  <a:srgbClr val="FF9D6C"/>
+                </a:solidFill>
+                <a:latin typeface="Consolas" pitchFamily="34" charset="0"/>
+                <a:ea typeface="Consolas" pitchFamily="34" charset="-122"/>
+                <a:cs typeface="Consolas" pitchFamily="34" charset="-120"/>
+              </a:rPr>
+              <a:t>print</a:t>
+            </a:r>
+            <a:r>
+              <a:rPr lang="en-US" sz="1400" dirty="0">
+                <a:solidFill>
+                  <a:srgbClr val="A9D4FF"/>
+                </a:solidFill>
+                <a:latin typeface="Consolas" pitchFamily="34" charset="0"/>
+                <a:ea typeface="Consolas" pitchFamily="34" charset="-122"/>
+                <a:cs typeface="Consolas" pitchFamily="34" charset="-120"/>
+              </a:rPr>
+              <a:t>(s[::</a:t>
+            </a:r>
+            <a:r>
+              <a:rPr lang="en-US" sz="1400" dirty="0">
+                <a:solidFill>
+                  <a:srgbClr val="3DC9B0"/>
+                </a:solidFill>
+                <a:latin typeface="Consolas" pitchFamily="34" charset="0"/>
+                <a:ea typeface="Consolas" pitchFamily="34" charset="-122"/>
+                <a:cs typeface="Consolas" pitchFamily="34" charset="-120"/>
+              </a:rPr>
+              <a:t>-1</a:t>
+            </a:r>
+            <a:r>
+              <a:rPr lang="en-US" sz="1400" dirty="0">
+                <a:solidFill>
+                  <a:srgbClr val="A9D4FF"/>
+                </a:solidFill>
+                <a:latin typeface="Consolas" pitchFamily="34" charset="0"/>
+                <a:ea typeface="Consolas" pitchFamily="34" charset="-122"/>
+                <a:cs typeface="Consolas" pitchFamily="34" charset="-120"/>
+              </a:rPr>
+              <a:t>])</a:t>
+            </a:r>
+            <a:r>
+              <a:rPr lang="en-US" sz="1400" dirty="0">
+                <a:solidFill>
+                  <a:srgbClr val="7A8BB5"/>
+                </a:solidFill>
+                <a:latin typeface="Consolas" pitchFamily="34" charset="0"/>
+                <a:ea typeface="Consolas" pitchFamily="34" charset="-122"/>
+                <a:cs typeface="Consolas" pitchFamily="34" charset="-120"/>
+              </a:rPr>
+              <a:t>    # "тіввирП"</a:t>
+            </a:r>
+            <a:endParaRPr lang="en-US" sz="1400" dirty="0"/>
+          </a:p>
+        </p:txBody>
+      </p:sp>
+      <p:sp>
+        <p:nvSpPr>
+          <p:cNvPr id="13" name="Shape 11"/>
+          <p:cNvSpPr/>
+          <p:nvPr/>
+        </p:nvSpPr>
+        <p:spPr>
+          <a:xfrm>
+            <a:off x="5349240" y="2103120"/>
+            <a:ext cx="3337560" cy="548640"/>
+          </a:xfrm>
+          <a:prstGeom prst="rect">
+            <a:avLst/>
+          </a:prstGeom>
+          <a:solidFill>
+            <a:srgbClr val="FFFFFF"/>
+          </a:solidFill>
+          <a:ln w="12700">
+            <a:solidFill>
+              <a:srgbClr val="E0E4F0"/>
+            </a:solidFill>
+            <a:prstDash val="solid"/>
+          </a:ln>
+          <a:effectLst>
+            <a:outerShdw blurRad="88900" dist="25400" dir="8100000" algn="bl" rotWithShape="0">
+              <a:srgbClr val="000000">
+                <a:alpha val="9000"/>
+              </a:srgbClr>
+            </a:outerShdw>
+          </a:effectLst>
+        </p:spPr>
+        <p:txBody>
+          <a:bodyPr/>
+          <a:lstStyle/>
+          <a:p>
+            <a:endParaRPr lang="en-UA"/>
+          </a:p>
+        </p:txBody>
+      </p:sp>
+      <p:sp>
+        <p:nvSpPr>
+          <p:cNvPr id="14" name="Shape 12"/>
+          <p:cNvSpPr/>
+          <p:nvPr/>
+        </p:nvSpPr>
+        <p:spPr>
+          <a:xfrm>
+            <a:off x="5349240" y="2103120"/>
+            <a:ext cx="54864" cy="548640"/>
+          </a:xfrm>
+          <a:prstGeom prst="rect">
+            <a:avLst/>
+          </a:prstGeom>
+          <a:solidFill>
+            <a:srgbClr val="5B8FF9"/>
+          </a:solidFill>
+          <a:ln w="12700">
+            <a:solidFill>
+              <a:srgbClr val="5B8FF9"/>
+            </a:solidFill>
+            <a:prstDash val="solid"/>
+          </a:ln>
+        </p:spPr>
+        <p:txBody>
+          <a:bodyPr/>
+          <a:lstStyle/>
+          <a:p>
+            <a:endParaRPr lang="en-UA"/>
+          </a:p>
+        </p:txBody>
+      </p:sp>
+      <p:sp>
+        <p:nvSpPr>
+          <p:cNvPr id="15" name="Text 13"/>
+          <p:cNvSpPr/>
+          <p:nvPr/>
+        </p:nvSpPr>
+        <p:spPr>
+          <a:xfrm>
+            <a:off x="5486400" y="2103120"/>
+            <a:ext cx="1371600" cy="548640"/>
+          </a:xfrm>
+          <a:prstGeom prst="rect">
+            <a:avLst/>
+          </a:prstGeom>
+          <a:noFill/>
+          <a:ln/>
+        </p:spPr>
+        <p:txBody>
+          <a:bodyPr wrap="square" lIns="0" tIns="0" rIns="0" bIns="0" rtlCol="0" anchor="ctr"/>
+          <a:lstStyle/>
+          <a:p>
+            <a:pPr marL="0" indent="0">
+              <a:buNone/>
+            </a:pPr>
+            <a:r>
+              <a:rPr lang="en-US" sz="1400" b="1" dirty="0">
+                <a:solidFill>
+                  <a:srgbClr val="5B8FF9"/>
+                </a:solidFill>
+                <a:latin typeface="Consolas" pitchFamily="34" charset="0"/>
+                <a:ea typeface="Consolas" pitchFamily="34" charset="-122"/>
+                <a:cs typeface="Consolas" pitchFamily="34" charset="-120"/>
+              </a:rPr>
+              <a:t>s[0:3]</a:t>
+            </a:r>
+            <a:endParaRPr lang="en-US" sz="1400" dirty="0"/>
+          </a:p>
+        </p:txBody>
+      </p:sp>
+      <p:sp>
+        <p:nvSpPr>
+          <p:cNvPr id="16" name="Text 14"/>
+          <p:cNvSpPr/>
+          <p:nvPr/>
+        </p:nvSpPr>
+        <p:spPr>
+          <a:xfrm>
+            <a:off x="6903720" y="2103120"/>
+            <a:ext cx="1691640" cy="292608"/>
+          </a:xfrm>
+          <a:prstGeom prst="rect">
+            <a:avLst/>
+          </a:prstGeom>
+          <a:noFill/>
+          <a:ln/>
+        </p:spPr>
+        <p:txBody>
+          <a:bodyPr wrap="square" lIns="0" tIns="0" rIns="0" bIns="0" rtlCol="0" anchor="ctr"/>
+          <a:lstStyle/>
+          <a:p>
+            <a:pPr marL="0" indent="0">
+              <a:buNone/>
+            </a:pPr>
+            <a:r>
+              <a:rPr lang="en-US" sz="1200" dirty="0">
+                <a:solidFill>
+                  <a:srgbClr val="6DDC8B"/>
+                </a:solidFill>
+                <a:latin typeface="Consolas" pitchFamily="34" charset="0"/>
+                <a:ea typeface="Consolas" pitchFamily="34" charset="-122"/>
+                <a:cs typeface="Consolas" pitchFamily="34" charset="-120"/>
+              </a:rPr>
+              <a:t>→ "При"</a:t>
+            </a:r>
+            <a:endParaRPr lang="en-US" sz="1200" dirty="0"/>
+          </a:p>
+        </p:txBody>
+      </p:sp>
+      <p:sp>
+        <p:nvSpPr>
+          <p:cNvPr id="17" name="Text 15"/>
+          <p:cNvSpPr/>
+          <p:nvPr/>
+        </p:nvSpPr>
+        <p:spPr>
+          <a:xfrm>
+            <a:off x="6903720" y="2377440"/>
+            <a:ext cx="1691640" cy="256032"/>
+          </a:xfrm>
+          <a:prstGeom prst="rect">
+            <a:avLst/>
+          </a:prstGeom>
+          <a:noFill/>
+          <a:ln/>
+        </p:spPr>
+        <p:txBody>
+          <a:bodyPr wrap="square" lIns="0" tIns="0" rIns="0" bIns="0" rtlCol="0" anchor="ctr"/>
+          <a:lstStyle/>
+          <a:p>
+            <a:pPr marL="0" indent="0">
+              <a:buNone/>
+            </a:pPr>
+            <a:r>
+              <a:rPr lang="en-US" sz="1000" dirty="0">
+                <a:solidFill>
+                  <a:srgbClr val="7A8BB5"/>
+                </a:solidFill>
+                <a:latin typeface="Calibri" pitchFamily="34" charset="0"/>
+                <a:ea typeface="Calibri" pitchFamily="34" charset="-122"/>
+                <a:cs typeface="Calibri" pitchFamily="34" charset="-120"/>
+              </a:rPr>
+              <a:t>символи 0, 1, 2</a:t>
+            </a:r>
+            <a:endParaRPr lang="en-US" sz="1000" dirty="0"/>
+          </a:p>
+        </p:txBody>
+      </p:sp>
+      <p:sp>
+        <p:nvSpPr>
+          <p:cNvPr id="18" name="Shape 16"/>
+          <p:cNvSpPr/>
+          <p:nvPr/>
+        </p:nvSpPr>
+        <p:spPr>
+          <a:xfrm>
+            <a:off x="5349240" y="2724912"/>
+            <a:ext cx="3337560" cy="548640"/>
+          </a:xfrm>
+          <a:prstGeom prst="rect">
+            <a:avLst/>
+          </a:prstGeom>
+          <a:solidFill>
+            <a:srgbClr val="FFFFFF"/>
+          </a:solidFill>
+          <a:ln w="12700">
+            <a:solidFill>
+              <a:srgbClr val="E0E4F0"/>
+            </a:solidFill>
+            <a:prstDash val="solid"/>
+          </a:ln>
+          <a:effectLst>
+            <a:outerShdw blurRad="88900" dist="25400" dir="8100000" algn="bl" rotWithShape="0">
+              <a:srgbClr val="000000">
+                <a:alpha val="9000"/>
+              </a:srgbClr>
+            </a:outerShdw>
+          </a:effectLst>
+        </p:spPr>
+        <p:txBody>
+          <a:bodyPr/>
+          <a:lstStyle/>
+          <a:p>
+            <a:endParaRPr lang="en-UA"/>
+          </a:p>
+        </p:txBody>
+      </p:sp>
+      <p:sp>
+        <p:nvSpPr>
+          <p:cNvPr id="19" name="Shape 17"/>
+          <p:cNvSpPr/>
+          <p:nvPr/>
+        </p:nvSpPr>
+        <p:spPr>
+          <a:xfrm>
+            <a:off x="5349240" y="2724912"/>
+            <a:ext cx="54864" cy="548640"/>
+          </a:xfrm>
+          <a:prstGeom prst="rect">
+            <a:avLst/>
+          </a:prstGeom>
+          <a:solidFill>
+            <a:srgbClr val="FF9D6C"/>
+          </a:solidFill>
+          <a:ln w="12700">
+            <a:solidFill>
+              <a:srgbClr val="FF9D6C"/>
+            </a:solidFill>
+            <a:prstDash val="solid"/>
+          </a:ln>
+        </p:spPr>
+        <p:txBody>
+          <a:bodyPr/>
+          <a:lstStyle/>
+          <a:p>
+            <a:endParaRPr lang="en-UA"/>
+          </a:p>
+        </p:txBody>
+      </p:sp>
+      <p:sp>
+        <p:nvSpPr>
+          <p:cNvPr id="20" name="Text 18"/>
+          <p:cNvSpPr/>
+          <p:nvPr/>
+        </p:nvSpPr>
+        <p:spPr>
+          <a:xfrm>
+            <a:off x="5486400" y="2724912"/>
+            <a:ext cx="1371600" cy="548640"/>
+          </a:xfrm>
+          <a:prstGeom prst="rect">
+            <a:avLst/>
+          </a:prstGeom>
+          <a:noFill/>
+          <a:ln/>
+        </p:spPr>
+        <p:txBody>
+          <a:bodyPr wrap="square" lIns="0" tIns="0" rIns="0" bIns="0" rtlCol="0" anchor="ctr"/>
+          <a:lstStyle/>
+          <a:p>
+            <a:pPr marL="0" indent="0">
+              <a:buNone/>
+            </a:pPr>
+            <a:r>
+              <a:rPr lang="en-US" sz="1400" b="1" dirty="0">
+                <a:solidFill>
+                  <a:srgbClr val="FF9D6C"/>
+                </a:solidFill>
+                <a:latin typeface="Consolas" pitchFamily="34" charset="0"/>
+                <a:ea typeface="Consolas" pitchFamily="34" charset="-122"/>
+                <a:cs typeface="Consolas" pitchFamily="34" charset="-120"/>
+              </a:rPr>
+              <a:t>s[3:]</a:t>
+            </a:r>
+            <a:endParaRPr lang="en-US" sz="1400" dirty="0"/>
+          </a:p>
+        </p:txBody>
+      </p:sp>
+      <p:sp>
+        <p:nvSpPr>
+          <p:cNvPr id="21" name="Text 19"/>
+          <p:cNvSpPr/>
+          <p:nvPr/>
+        </p:nvSpPr>
+        <p:spPr>
+          <a:xfrm>
+            <a:off x="6903720" y="2724912"/>
+            <a:ext cx="1691640" cy="292608"/>
+          </a:xfrm>
+          <a:prstGeom prst="rect">
+            <a:avLst/>
+          </a:prstGeom>
+          <a:noFill/>
+          <a:ln/>
+        </p:spPr>
+        <p:txBody>
+          <a:bodyPr wrap="square" lIns="0" tIns="0" rIns="0" bIns="0" rtlCol="0" anchor="ctr"/>
+          <a:lstStyle/>
+          <a:p>
+            <a:pPr marL="0" indent="0">
+              <a:buNone/>
+            </a:pPr>
+            <a:r>
+              <a:rPr lang="en-US" sz="1200" dirty="0">
+                <a:solidFill>
+                  <a:srgbClr val="6DDC8B"/>
+                </a:solidFill>
+                <a:latin typeface="Consolas" pitchFamily="34" charset="0"/>
+                <a:ea typeface="Consolas" pitchFamily="34" charset="-122"/>
+                <a:cs typeface="Consolas" pitchFamily="34" charset="-120"/>
+              </a:rPr>
+              <a:t>→ "віт"</a:t>
+            </a:r>
+            <a:endParaRPr lang="en-US" sz="1200" dirty="0"/>
+          </a:p>
+        </p:txBody>
+      </p:sp>
+      <p:sp>
+        <p:nvSpPr>
+          <p:cNvPr id="22" name="Text 20"/>
+          <p:cNvSpPr/>
+          <p:nvPr/>
+        </p:nvSpPr>
+        <p:spPr>
+          <a:xfrm>
+            <a:off x="6903720" y="2999232"/>
+            <a:ext cx="1691640" cy="256032"/>
+          </a:xfrm>
+          <a:prstGeom prst="rect">
+            <a:avLst/>
+          </a:prstGeom>
+          <a:noFill/>
+          <a:ln/>
+        </p:spPr>
+        <p:txBody>
+          <a:bodyPr wrap="square" lIns="0" tIns="0" rIns="0" bIns="0" rtlCol="0" anchor="ctr"/>
+          <a:lstStyle/>
+          <a:p>
+            <a:pPr marL="0" indent="0">
+              <a:buNone/>
+            </a:pPr>
+            <a:r>
+              <a:rPr lang="en-US" sz="1000" dirty="0">
+                <a:solidFill>
+                  <a:srgbClr val="7A8BB5"/>
+                </a:solidFill>
+                <a:latin typeface="Calibri" pitchFamily="34" charset="0"/>
+                <a:ea typeface="Calibri" pitchFamily="34" charset="-122"/>
+                <a:cs typeface="Calibri" pitchFamily="34" charset="-120"/>
+              </a:rPr>
+              <a:t>від 3 до кінця</a:t>
+            </a:r>
+            <a:endParaRPr lang="en-US" sz="1000" dirty="0"/>
+          </a:p>
+        </p:txBody>
+      </p:sp>
+      <p:sp>
+        <p:nvSpPr>
+          <p:cNvPr id="23" name="Shape 21"/>
+          <p:cNvSpPr/>
+          <p:nvPr/>
+        </p:nvSpPr>
+        <p:spPr>
+          <a:xfrm>
+            <a:off x="5349240" y="3346704"/>
+            <a:ext cx="3337560" cy="548640"/>
+          </a:xfrm>
+          <a:prstGeom prst="rect">
+            <a:avLst/>
+          </a:prstGeom>
+          <a:solidFill>
+            <a:srgbClr val="FFFFFF"/>
+          </a:solidFill>
+          <a:ln w="12700">
+            <a:solidFill>
+              <a:srgbClr val="E0E4F0"/>
+            </a:solidFill>
+            <a:prstDash val="solid"/>
+          </a:ln>
+          <a:effectLst>
+            <a:outerShdw blurRad="88900" dist="25400" dir="8100000" algn="bl" rotWithShape="0">
+              <a:srgbClr val="000000">
+                <a:alpha val="9000"/>
+              </a:srgbClr>
+            </a:outerShdw>
+          </a:effectLst>
+        </p:spPr>
+        <p:txBody>
+          <a:bodyPr/>
+          <a:lstStyle/>
+          <a:p>
+            <a:endParaRPr lang="en-UA"/>
+          </a:p>
+        </p:txBody>
+      </p:sp>
+      <p:sp>
+        <p:nvSpPr>
+          <p:cNvPr id="24" name="Shape 22"/>
+          <p:cNvSpPr/>
+          <p:nvPr/>
+        </p:nvSpPr>
+        <p:spPr>
+          <a:xfrm>
+            <a:off x="5349240" y="3346704"/>
+            <a:ext cx="54864" cy="548640"/>
+          </a:xfrm>
+          <a:prstGeom prst="rect">
+            <a:avLst/>
+          </a:prstGeom>
+          <a:solidFill>
+            <a:srgbClr val="3DC9B0"/>
+          </a:solidFill>
+          <a:ln w="12700">
+            <a:solidFill>
+              <a:srgbClr val="3DC9B0"/>
+            </a:solidFill>
+            <a:prstDash val="solid"/>
+          </a:ln>
+        </p:spPr>
+        <p:txBody>
+          <a:bodyPr/>
+          <a:lstStyle/>
+          <a:p>
+            <a:endParaRPr lang="en-UA"/>
+          </a:p>
+        </p:txBody>
+      </p:sp>
+      <p:sp>
+        <p:nvSpPr>
+          <p:cNvPr id="25" name="Text 23"/>
+          <p:cNvSpPr/>
+          <p:nvPr/>
+        </p:nvSpPr>
+        <p:spPr>
+          <a:xfrm>
+            <a:off x="5486400" y="3346704"/>
+            <a:ext cx="1371600" cy="548640"/>
+          </a:xfrm>
+          <a:prstGeom prst="rect">
+            <a:avLst/>
+          </a:prstGeom>
+          <a:noFill/>
+          <a:ln/>
+        </p:spPr>
+        <p:txBody>
+          <a:bodyPr wrap="square" lIns="0" tIns="0" rIns="0" bIns="0" rtlCol="0" anchor="ctr"/>
+          <a:lstStyle/>
+          <a:p>
+            <a:pPr marL="0" indent="0">
+              <a:buNone/>
+            </a:pPr>
+            <a:r>
+              <a:rPr lang="en-US" sz="1400" b="1" dirty="0">
+                <a:solidFill>
+                  <a:srgbClr val="3DC9B0"/>
+                </a:solidFill>
+                <a:latin typeface="Consolas" pitchFamily="34" charset="0"/>
+                <a:ea typeface="Consolas" pitchFamily="34" charset="-122"/>
+                <a:cs typeface="Consolas" pitchFamily="34" charset="-120"/>
+              </a:rPr>
+              <a:t>s[:3]</a:t>
+            </a:r>
+            <a:endParaRPr lang="en-US" sz="1400" dirty="0"/>
+          </a:p>
+        </p:txBody>
+      </p:sp>
+      <p:sp>
+        <p:nvSpPr>
+          <p:cNvPr id="26" name="Text 24"/>
+          <p:cNvSpPr/>
+          <p:nvPr/>
+        </p:nvSpPr>
+        <p:spPr>
+          <a:xfrm>
+            <a:off x="6903720" y="3346704"/>
+            <a:ext cx="1691640" cy="292608"/>
+          </a:xfrm>
+          <a:prstGeom prst="rect">
+            <a:avLst/>
+          </a:prstGeom>
+          <a:noFill/>
+          <a:ln/>
+        </p:spPr>
+        <p:txBody>
+          <a:bodyPr wrap="square" lIns="0" tIns="0" rIns="0" bIns="0" rtlCol="0" anchor="ctr"/>
+          <a:lstStyle/>
+          <a:p>
+            <a:pPr marL="0" indent="0">
+              <a:buNone/>
+            </a:pPr>
+            <a:r>
+              <a:rPr lang="en-US" sz="1200" dirty="0">
+                <a:solidFill>
+                  <a:srgbClr val="6DDC8B"/>
+                </a:solidFill>
+                <a:latin typeface="Consolas" pitchFamily="34" charset="0"/>
+                <a:ea typeface="Consolas" pitchFamily="34" charset="-122"/>
+                <a:cs typeface="Consolas" pitchFamily="34" charset="-120"/>
+              </a:rPr>
+              <a:t>→ "При"</a:t>
+            </a:r>
+            <a:endParaRPr lang="en-US" sz="1200" dirty="0"/>
+          </a:p>
+        </p:txBody>
+      </p:sp>
+      <p:sp>
+        <p:nvSpPr>
+          <p:cNvPr id="27" name="Text 25"/>
+          <p:cNvSpPr/>
+          <p:nvPr/>
+        </p:nvSpPr>
+        <p:spPr>
+          <a:xfrm>
+            <a:off x="6903720" y="3621024"/>
+            <a:ext cx="1691640" cy="256032"/>
+          </a:xfrm>
+          <a:prstGeom prst="rect">
+            <a:avLst/>
+          </a:prstGeom>
+          <a:noFill/>
+          <a:ln/>
+        </p:spPr>
+        <p:txBody>
+          <a:bodyPr wrap="square" lIns="0" tIns="0" rIns="0" bIns="0" rtlCol="0" anchor="ctr"/>
+          <a:lstStyle/>
+          <a:p>
+            <a:pPr marL="0" indent="0">
+              <a:buNone/>
+            </a:pPr>
+            <a:r>
+              <a:rPr lang="en-US" sz="1000" dirty="0">
+                <a:solidFill>
+                  <a:srgbClr val="7A8BB5"/>
+                </a:solidFill>
+                <a:latin typeface="Calibri" pitchFamily="34" charset="0"/>
+                <a:ea typeface="Calibri" pitchFamily="34" charset="-122"/>
+                <a:cs typeface="Calibri" pitchFamily="34" charset="-120"/>
+              </a:rPr>
+              <a:t>від початку до 3</a:t>
+            </a:r>
+            <a:endParaRPr lang="en-US" sz="1000" dirty="0"/>
+          </a:p>
+        </p:txBody>
+      </p:sp>
+      <p:sp>
+        <p:nvSpPr>
+          <p:cNvPr id="28" name="Shape 26"/>
+          <p:cNvSpPr/>
+          <p:nvPr/>
+        </p:nvSpPr>
+        <p:spPr>
+          <a:xfrm>
+            <a:off x="5349240" y="3968496"/>
+            <a:ext cx="3337560" cy="548640"/>
+          </a:xfrm>
+          <a:prstGeom prst="rect">
+            <a:avLst/>
+          </a:prstGeom>
+          <a:solidFill>
+            <a:srgbClr val="FFFFFF"/>
+          </a:solidFill>
+          <a:ln w="12700">
+            <a:solidFill>
+              <a:srgbClr val="E0E4F0"/>
+            </a:solidFill>
+            <a:prstDash val="solid"/>
+          </a:ln>
+          <a:effectLst>
+            <a:outerShdw blurRad="88900" dist="25400" dir="8100000" algn="bl" rotWithShape="0">
+              <a:srgbClr val="000000">
+                <a:alpha val="9000"/>
+              </a:srgbClr>
+            </a:outerShdw>
+          </a:effectLst>
+        </p:spPr>
+        <p:txBody>
+          <a:bodyPr/>
+          <a:lstStyle/>
+          <a:p>
+            <a:endParaRPr lang="en-UA"/>
+          </a:p>
+        </p:txBody>
+      </p:sp>
+      <p:sp>
+        <p:nvSpPr>
+          <p:cNvPr id="29" name="Shape 27"/>
+          <p:cNvSpPr/>
+          <p:nvPr/>
+        </p:nvSpPr>
+        <p:spPr>
+          <a:xfrm>
+            <a:off x="5349240" y="3968496"/>
+            <a:ext cx="54864" cy="548640"/>
+          </a:xfrm>
+          <a:prstGeom prst="rect">
+            <a:avLst/>
+          </a:prstGeom>
+          <a:solidFill>
+            <a:srgbClr val="C9A0FF"/>
+          </a:solidFill>
+          <a:ln w="12700">
+            <a:solidFill>
+              <a:srgbClr val="C9A0FF"/>
+            </a:solidFill>
+            <a:prstDash val="solid"/>
+          </a:ln>
+        </p:spPr>
+        <p:txBody>
+          <a:bodyPr/>
+          <a:lstStyle/>
+          <a:p>
+            <a:endParaRPr lang="en-UA"/>
+          </a:p>
+        </p:txBody>
+      </p:sp>
+      <p:sp>
+        <p:nvSpPr>
+          <p:cNvPr id="30" name="Text 28"/>
+          <p:cNvSpPr/>
+          <p:nvPr/>
+        </p:nvSpPr>
+        <p:spPr>
+          <a:xfrm>
+            <a:off x="5486400" y="3968496"/>
+            <a:ext cx="1371600" cy="548640"/>
+          </a:xfrm>
+          <a:prstGeom prst="rect">
+            <a:avLst/>
+          </a:prstGeom>
+          <a:noFill/>
+          <a:ln/>
+        </p:spPr>
+        <p:txBody>
+          <a:bodyPr wrap="square" lIns="0" tIns="0" rIns="0" bIns="0" rtlCol="0" anchor="ctr"/>
+          <a:lstStyle/>
+          <a:p>
+            <a:pPr marL="0" indent="0">
+              <a:buNone/>
+            </a:pPr>
+            <a:r>
+              <a:rPr lang="en-US" sz="1400" b="1" dirty="0">
+                <a:solidFill>
+                  <a:srgbClr val="C9A0FF"/>
+                </a:solidFill>
+                <a:latin typeface="Consolas" pitchFamily="34" charset="0"/>
+                <a:ea typeface="Consolas" pitchFamily="34" charset="-122"/>
+                <a:cs typeface="Consolas" pitchFamily="34" charset="-120"/>
+              </a:rPr>
+              <a:t>s[::-1]</a:t>
+            </a:r>
+            <a:endParaRPr lang="en-US" sz="1400" dirty="0"/>
+          </a:p>
+        </p:txBody>
+      </p:sp>
+      <p:sp>
+        <p:nvSpPr>
+          <p:cNvPr id="31" name="Text 29"/>
+          <p:cNvSpPr/>
+          <p:nvPr/>
+        </p:nvSpPr>
+        <p:spPr>
+          <a:xfrm>
+            <a:off x="6903720" y="3968496"/>
+            <a:ext cx="1691640" cy="292608"/>
+          </a:xfrm>
+          <a:prstGeom prst="rect">
+            <a:avLst/>
+          </a:prstGeom>
+          <a:noFill/>
+          <a:ln/>
+        </p:spPr>
+        <p:txBody>
+          <a:bodyPr wrap="square" lIns="0" tIns="0" rIns="0" bIns="0" rtlCol="0" anchor="ctr"/>
+          <a:lstStyle/>
+          <a:p>
+            <a:pPr marL="0" indent="0">
+              <a:buNone/>
+            </a:pPr>
+            <a:r>
+              <a:rPr lang="en-US" sz="1200" dirty="0">
+                <a:solidFill>
+                  <a:srgbClr val="6DDC8B"/>
+                </a:solidFill>
+                <a:latin typeface="Consolas" pitchFamily="34" charset="0"/>
+                <a:ea typeface="Consolas" pitchFamily="34" charset="-122"/>
+                <a:cs typeface="Consolas" pitchFamily="34" charset="-120"/>
+              </a:rPr>
+              <a:t>→ "тіввирП"</a:t>
+            </a:r>
+            <a:endParaRPr lang="en-US" sz="1200" dirty="0"/>
+          </a:p>
+        </p:txBody>
+      </p:sp>
+      <p:sp>
+        <p:nvSpPr>
+          <p:cNvPr id="32" name="Text 30"/>
+          <p:cNvSpPr/>
+          <p:nvPr/>
+        </p:nvSpPr>
+        <p:spPr>
+          <a:xfrm>
+            <a:off x="6903720" y="4242816"/>
+            <a:ext cx="1691640" cy="256032"/>
+          </a:xfrm>
+          <a:prstGeom prst="rect">
+            <a:avLst/>
+          </a:prstGeom>
+          <a:noFill/>
+          <a:ln/>
+        </p:spPr>
+        <p:txBody>
+          <a:bodyPr wrap="square" lIns="0" tIns="0" rIns="0" bIns="0" rtlCol="0" anchor="ctr"/>
+          <a:lstStyle/>
+          <a:p>
+            <a:pPr marL="0" indent="0">
+              <a:buNone/>
+            </a:pPr>
+            <a:r>
+              <a:rPr lang="en-US" sz="1000" dirty="0">
+                <a:solidFill>
+                  <a:srgbClr val="7A8BB5"/>
+                </a:solidFill>
+                <a:latin typeface="Calibri" pitchFamily="34" charset="0"/>
+                <a:ea typeface="Calibri" pitchFamily="34" charset="-122"/>
+                <a:cs typeface="Calibri" pitchFamily="34" charset="-120"/>
+              </a:rPr>
+              <a:t>рядок задом наперед</a:t>
+            </a:r>
+            <a:endParaRPr lang="en-US" sz="1000" dirty="0"/>
+          </a:p>
+        </p:txBody>
+      </p:sp>
+      <p:sp>
+        <p:nvSpPr>
+          <p:cNvPr id="33" name="Shape 31"/>
+          <p:cNvSpPr/>
+          <p:nvPr/>
+        </p:nvSpPr>
+        <p:spPr>
+          <a:xfrm>
+            <a:off x="457200" y="4736592"/>
+            <a:ext cx="8229600" cy="347472"/>
+          </a:xfrm>
+          <a:prstGeom prst="rect">
+            <a:avLst/>
+          </a:prstGeom>
+          <a:solidFill>
+            <a:srgbClr val="000000"/>
+          </a:solidFill>
+          <a:ln w="12700">
+            <a:solidFill>
+              <a:srgbClr val="5B8FF9"/>
+            </a:solidFill>
+            <a:prstDash val="solid"/>
+          </a:ln>
+        </p:spPr>
+        <p:txBody>
+          <a:bodyPr/>
+          <a:lstStyle/>
+          <a:p>
+            <a:endParaRPr lang="en-UA"/>
+          </a:p>
+        </p:txBody>
+      </p:sp>
+      <p:sp>
+        <p:nvSpPr>
+          <p:cNvPr id="34" name="Text 32"/>
+          <p:cNvSpPr/>
+          <p:nvPr/>
+        </p:nvSpPr>
+        <p:spPr>
+          <a:xfrm>
+            <a:off x="594360" y="4736592"/>
+            <a:ext cx="7955280" cy="347472"/>
+          </a:xfrm>
+          <a:prstGeom prst="rect">
+            <a:avLst/>
+          </a:prstGeom>
+          <a:noFill/>
+          <a:ln/>
+        </p:spPr>
+        <p:txBody>
+          <a:bodyPr wrap="square" lIns="0" tIns="0" rIns="0" bIns="0" rtlCol="0" anchor="ctr"/>
+          <a:lstStyle/>
+          <a:p>
+            <a:pPr marL="0" indent="0" algn="ctr">
+              <a:buNone/>
+            </a:pPr>
+            <a:r>
+              <a:rPr lang="en-US" sz="1300" dirty="0">
+                <a:solidFill>
+                  <a:schemeClr val="accent4">
+                    <a:lumMod val="60000"/>
+                    <a:lumOff val="40000"/>
+                  </a:schemeClr>
+                </a:solidFill>
+                <a:latin typeface="Calibri" pitchFamily="34" charset="0"/>
+                <a:ea typeface="Calibri" pitchFamily="34" charset="-122"/>
+                <a:cs typeface="Calibri" pitchFamily="34" charset="-120"/>
+              </a:rPr>
+              <a:t>Рядки в Python незмінні — зріз повертає новий рядок, не змінює оригінал</a:t>
+            </a:r>
+            <a:endParaRPr lang="en-US" sz="1300" dirty="0">
+              <a:solidFill>
+                <a:schemeClr val="accent4">
+                  <a:lumMod val="60000"/>
+                  <a:lumOff val="40000"/>
+                </a:schemeClr>
+              </a:solidFill>
+            </a:endParaRPr>
+          </a:p>
+        </p:txBody>
+      </p:sp>
+    </p:spTree>
+  </p:cSld>
+  <p:clrMapOvr>
+    <a:masterClrMapping/>
+  </p:clrMapOvr>
+</p:sld>
+</file>
+
+<file path=ppt/slides/slide17.xml><?xml version="1.0" encoding="utf-8"?>
 <p:sld xmlns:a="http://schemas.openxmlformats.org/drawingml/2006/main" xmlns:r="http://schemas.openxmlformats.org/officeDocument/2006/relationships" xmlns:p="http://schemas.openxmlformats.org/presentationml/2006/main">
   <p:cSld name="Slide 15">
     <p:bg>

</xml_diff>